<commit_message>
+update final presentation  for FoodScope
</commit_message>
<xml_diff>
--- a/presentation/FoodScope.pptx
+++ b/presentation/FoodScope.pptx
@@ -5,7 +5,7 @@
     <p:sldMasterId id="2147483648" r:id="rId1"/>
   </p:sldMasterIdLst>
   <p:notesMasterIdLst>
-    <p:notesMasterId r:id="rId14"/>
+    <p:notesMasterId r:id="rId13"/>
   </p:notesMasterIdLst>
   <p:sldIdLst>
     <p:sldId id="256" r:id="rId2"/>
@@ -18,8 +18,7 @@
     <p:sldId id="263" r:id="rId9"/>
     <p:sldId id="264" r:id="rId10"/>
     <p:sldId id="265" r:id="rId11"/>
-    <p:sldId id="266" r:id="rId12"/>
-    <p:sldId id="267" r:id="rId13"/>
+    <p:sldId id="267" r:id="rId12"/>
   </p:sldIdLst>
   <p:sldSz cx="12192000" cy="6858000"/>
   <p:notesSz cx="6858000" cy="12192000"/>
@@ -169,9 +168,7 @@
           </p14:sldIdLst>
         </p14:section>
         <p14:section name="9 Open problem" id="{A06A0D32-FCF0-EBA5-02B0-FFA64960F805}">
-          <p14:sldIdLst>
-            <p14:sldId id="266"/>
-          </p14:sldIdLst>
+          <p14:sldIdLst/>
         </p14:section>
         <p14:section name="Closing" id="{A0FB85CB-CD30-1C41-A80B-46723D1D3206}">
           <p14:sldIdLst>
@@ -1184,90 +1181,6 @@
 </p:notes>
 </file>
 
-<file path=ppt/notesSlides/notesSlide12.xml><?xml version="1.0" encoding="utf-8"?>
-<p:notes xmlns:a="http://schemas.openxmlformats.org/drawingml/2006/main" xmlns:r="http://schemas.openxmlformats.org/officeDocument/2006/relationships" xmlns:p="http://schemas.openxmlformats.org/presentationml/2006/main">
-  <p:cSld>
-    <p:spTree>
-      <p:nvGrpSpPr>
-        <p:cNvPr id="1" name=""/>
-        <p:cNvGrpSpPr/>
-        <p:nvPr/>
-      </p:nvGrpSpPr>
-      <p:grpSpPr>
-        <a:xfrm>
-          <a:off x="0" y="0"/>
-          <a:ext cx="0" cy="0"/>
-          <a:chOff x="0" y="0"/>
-          <a:chExt cx="0" cy="0"/>
-        </a:xfrm>
-      </p:grpSpPr>
-      <p:sp>
-        <p:nvSpPr>
-          <p:cNvPr id="2" name="Slide Image Placeholder 1"/>
-          <p:cNvSpPr>
-            <a:spLocks noGrp="1" noRot="1" noChangeAspect="1"/>
-          </p:cNvSpPr>
-          <p:nvPr>
-            <p:ph type="sldImg"/>
-          </p:nvPr>
-        </p:nvSpPr>
-        <p:spPr/>
-      </p:sp>
-      <p:sp>
-        <p:nvSpPr>
-          <p:cNvPr id="3" name="Notes Placeholder 2"/>
-          <p:cNvSpPr>
-            <a:spLocks noGrp="1"/>
-          </p:cNvSpPr>
-          <p:nvPr>
-            <p:ph type="body" idx="1"/>
-          </p:nvPr>
-        </p:nvSpPr>
-        <p:spPr/>
-        <p:txBody>
-          <a:bodyPr/>
-          <a:lstStyle/>
-          <a:p>
-            <a:endParaRPr lang="en-US" dirty="0"/>
-          </a:p>
-        </p:txBody>
-      </p:sp>
-      <p:sp>
-        <p:nvSpPr>
-          <p:cNvPr id="4" name="Slide Number Placeholder 3"/>
-          <p:cNvSpPr>
-            <a:spLocks noGrp="1"/>
-          </p:cNvSpPr>
-          <p:nvPr>
-            <p:ph type="sldNum" sz="quarter" idx="10"/>
-          </p:nvPr>
-        </p:nvSpPr>
-        <p:spPr/>
-        <p:txBody>
-          <a:bodyPr/>
-          <a:lstStyle/>
-          <a:p>
-            <a:fld id="{F7021451-1387-4CA6-816F-3879F97B5CBC}" type="slidenum">
-              <a:rPr lang="en-US"/>
-              <a:t>12</a:t>
-            </a:fld>
-            <a:endParaRPr lang="en-US"/>
-          </a:p>
-        </p:txBody>
-      </p:sp>
-    </p:spTree>
-    <p:extLst>
-      <p:ext uri="{BB962C8B-B14F-4D97-AF65-F5344CB8AC3E}">
-        <p14:creationId xmlns:p14="http://schemas.microsoft.com/office/powerpoint/2010/main" val="1024086991"/>
-      </p:ext>
-    </p:extLst>
-  </p:cSld>
-  <p:clrMapOvr>
-    <a:masterClrMapping/>
-  </p:clrMapOvr>
-</p:notes>
-</file>
-
 <file path=ppt/notesSlides/notesSlide2.xml><?xml version="1.0" encoding="utf-8"?>
 <p:notes xmlns:a="http://schemas.openxmlformats.org/drawingml/2006/main" xmlns:r="http://schemas.openxmlformats.org/officeDocument/2006/relationships" xmlns:p="http://schemas.openxmlformats.org/presentationml/2006/main">
   <p:cSld>
@@ -2219,7 +2132,7 @@
           </a:prstGeom>
           <a:extLst>
             <a:ext uri="{C572A759-6A51-4108-AA02-DFA0A04FC94B}">
-              <ma14:wrappingTextBoxFlag xmlns:ma14="http://schemas.microsoft.com/office/mac/drawingml/2011/main" xmlns="" val="0"/>
+              <ma14:wrappingTextBoxFlag xmlns="" xmlns:ma14="http://schemas.microsoft.com/office/mac/drawingml/2011/main" val="0"/>
             </a:ext>
           </a:extLst>
         </p:spPr>
@@ -2294,7 +2207,7 @@
           </a:prstGeom>
           <a:extLst>
             <a:ext uri="{C572A759-6A51-4108-AA02-DFA0A04FC94B}">
-              <ma14:wrappingTextBoxFlag xmlns:ma14="http://schemas.microsoft.com/office/mac/drawingml/2011/main" xmlns="" val="0"/>
+              <ma14:wrappingTextBoxFlag xmlns="" xmlns:ma14="http://schemas.microsoft.com/office/mac/drawingml/2011/main" val="0"/>
             </a:ext>
           </a:extLst>
         </p:spPr>
@@ -5076,21 +4989,94 @@
           <a:bodyPr wrap="square" lIns="0" tIns="0" rIns="0" bIns="0" rtlCol="0" anchor="ctr"/>
           <a:lstStyle/>
           <a:p>
-            <a:pPr marL="0" indent="0">
-              <a:lnSpc>
-                <a:spcPct val="100000"/>
-              </a:lnSpc>
-              <a:buNone/>
-            </a:pPr>
             <a:r>
               <a:rPr lang="en-US" sz="1400" dirty="0">
                 <a:solidFill>
                   <a:schemeClr val="bg1"/>
                 </a:solidFill>
               </a:rPr>
-              <a:t>The whole system starts with one command. Fuseki serves the graph, the pipeline runs once and stops everything if the data fails the gate, and the access layer serves questions and our web page. Every port listens only on this computer, and the key lives only in .env. Our first clean checkout test found one broken Docker file; we fixed it, and the second test passed all eight pipeline steps.</a:t>
+              <a:t>We start the system with </a:t>
             </a:r>
-            <a:endParaRPr lang="en-US" sz="1400" dirty="0"/>
+            <a:r>
+              <a:rPr lang="en-US" b="1" dirty="0">
+                <a:solidFill>
+                  <a:schemeClr val="bg1"/>
+                </a:solidFill>
+              </a:rPr>
+              <a:t>docker compose up --build</a:t>
+            </a:r>
+            <a:r>
+              <a:rPr lang="en-US" sz="1400" dirty="0">
+                <a:solidFill>
+                  <a:schemeClr val="bg1"/>
+                </a:solidFill>
+              </a:rPr>
+              <a:t>. </a:t>
+            </a:r>
+            <a:r>
+              <a:rPr lang="en-US" sz="1400" b="1" dirty="0" err="1">
+                <a:solidFill>
+                  <a:schemeClr val="bg1"/>
+                </a:solidFill>
+              </a:rPr>
+              <a:t>Fuseki</a:t>
+            </a:r>
+            <a:r>
+              <a:rPr lang="en-US" sz="1400" dirty="0">
+                <a:solidFill>
+                  <a:schemeClr val="bg1"/>
+                </a:solidFill>
+              </a:rPr>
+              <a:t> hosts the knowledge graph and answers SPARQL queries. The </a:t>
+            </a:r>
+            <a:r>
+              <a:rPr lang="en-US" sz="1400" b="1" dirty="0">
+                <a:solidFill>
+                  <a:schemeClr val="bg1"/>
+                </a:solidFill>
+              </a:rPr>
+              <a:t>pipeline</a:t>
+            </a:r>
+            <a:r>
+              <a:rPr lang="en-US" sz="1400" dirty="0">
+                <a:solidFill>
+                  <a:schemeClr val="bg1"/>
+                </a:solidFill>
+              </a:rPr>
+              <a:t> builds and validates the graph, stopping processing if a blocking SHACL violation is found. The </a:t>
+            </a:r>
+            <a:r>
+              <a:rPr lang="en-US" sz="1400" b="1" dirty="0">
+                <a:solidFill>
+                  <a:schemeClr val="bg1"/>
+                </a:solidFill>
+              </a:rPr>
+              <a:t>access layer</a:t>
+            </a:r>
+            <a:r>
+              <a:rPr lang="en-US" sz="1400" dirty="0">
+                <a:solidFill>
+                  <a:schemeClr val="bg1"/>
+                </a:solidFill>
+              </a:rPr>
+              <a:t> provides the web page and natural-language questions. Services are accessible only from this computer, and API keys are stored in </a:t>
+            </a:r>
+            <a:r>
+              <a:rPr lang="en-US" dirty="0">
+                <a:solidFill>
+                  <a:schemeClr val="bg1"/>
+                </a:solidFill>
+              </a:rPr>
+              <a:t>.env</a:t>
+            </a:r>
+            <a:r>
+              <a:rPr lang="en-US" sz="1400" dirty="0">
+                <a:solidFill>
+                  <a:schemeClr val="bg1"/>
+                </a:solidFill>
+              </a:rPr>
+              <a:t>. After fixing a Docker configuration issue, our clean-checkout test passed all eight pipeline steps.</a:t>
+            </a:r>
           </a:p>
         </p:txBody>
       </p:sp>
@@ -5114,7 +5100,7 @@
           </a:prstGeom>
           <a:extLst>
             <a:ext uri="{C572A759-6A51-4108-AA02-DFA0A04FC94B}">
-              <ma14:wrappingTextBoxFlag xmlns:ma14="http://schemas.microsoft.com/office/mac/drawingml/2011/main" xmlns="" val="0"/>
+              <ma14:wrappingTextBoxFlag xmlns="" xmlns:ma14="http://schemas.microsoft.com/office/mac/drawingml/2011/main" val="0"/>
             </a:ext>
           </a:extLst>
         </p:spPr>
@@ -6715,1864 +6701,6 @@
 
 <file path=ppt/slides/slide11.xml><?xml version="1.0" encoding="utf-8"?>
 <p:sld xmlns:a="http://schemas.openxmlformats.org/drawingml/2006/main" xmlns:r="http://schemas.openxmlformats.org/officeDocument/2006/relationships" xmlns:p="http://schemas.openxmlformats.org/presentationml/2006/main">
-  <p:cSld name="Slide 11">
-    <p:spTree>
-      <p:nvGrpSpPr>
-        <p:cNvPr id="1" name=""/>
-        <p:cNvGrpSpPr/>
-        <p:nvPr/>
-      </p:nvGrpSpPr>
-      <p:grpSpPr>
-        <a:xfrm>
-          <a:off x="0" y="0"/>
-          <a:ext cx="0" cy="0"/>
-          <a:chOff x="0" y="0"/>
-          <a:chExt cx="0" cy="0"/>
-        </a:xfrm>
-      </p:grpSpPr>
-      <p:sp>
-        <p:nvSpPr>
-          <p:cNvPr id="2" name="Text 0"/>
-          <p:cNvSpPr>
-            <a:spLocks noGrp="1"/>
-          </p:cNvSpPr>
-          <p:nvPr>
-            <p:ph type="title" idx="100" hasCustomPrompt="1"/>
-          </p:nvPr>
-        </p:nvSpPr>
-        <p:spPr>
-          <a:xfrm>
-            <a:off x="548640" y="347472"/>
-            <a:ext cx="9052560" cy="640080"/>
-          </a:xfrm>
-          <a:prstGeom prst="rect">
-            <a:avLst/>
-          </a:prstGeom>
-          <a:noFill/>
-          <a:ln/>
-        </p:spPr>
-        <p:txBody>
-          <a:bodyPr wrap="square" lIns="0" tIns="0" rIns="0" bIns="0" rtlCol="0" anchor="t"/>
-          <a:lstStyle/>
-          <a:p>
-            <a:pPr marL="0" indent="0" algn="l">
-              <a:buNone/>
-            </a:pPr>
-            <a:r>
-              <a:rPr lang="en-US" sz="3400" b="1" dirty="0">
-                <a:solidFill>
-                  <a:schemeClr val="tx2"/>
-                </a:solidFill>
-              </a:rPr>
-              <a:t>Open problem: reproducible results</a:t>
-            </a:r>
-            <a:endParaRPr lang="en-US" sz="3400" dirty="0"/>
-          </a:p>
-        </p:txBody>
-      </p:sp>
-      <p:sp>
-        <p:nvSpPr>
-          <p:cNvPr id="3" name="Text 0"/>
-          <p:cNvSpPr>
-            <a:spLocks noGrp="1"/>
-          </p:cNvSpPr>
-          <p:nvPr>
-            <p:ph type="body" idx="101" hasCustomPrompt="1"/>
-          </p:nvPr>
-        </p:nvSpPr>
-        <p:spPr>
-          <a:xfrm>
-            <a:off x="548640" y="987552"/>
-            <a:ext cx="9326880" cy="411480"/>
-          </a:xfrm>
-          <a:prstGeom prst="rect">
-            <a:avLst/>
-          </a:prstGeom>
-          <a:noFill/>
-          <a:ln/>
-        </p:spPr>
-        <p:txBody>
-          <a:bodyPr wrap="square" lIns="0" tIns="0" rIns="0" bIns="0" rtlCol="0" anchor="t"/>
-          <a:lstStyle/>
-          <a:p>
-            <a:pPr marL="0" indent="0">
-              <a:buNone/>
-            </a:pPr>
-            <a:r>
-              <a:rPr lang="en-US" sz="1900" dirty="0">
-                <a:solidFill>
-                  <a:schemeClr val="accent2"/>
-                </a:solidFill>
-              </a:rPr>
-              <a:t>When a model loses to a count, what did we learn?</a:t>
-            </a:r>
-            <a:endParaRPr lang="en-US" sz="1900" dirty="0"/>
-          </a:p>
-        </p:txBody>
-      </p:sp>
-      <p:sp>
-        <p:nvSpPr>
-          <p:cNvPr id="4" name="a0_chip"/>
-          <p:cNvSpPr txBox="1"/>
-          <p:nvPr/>
-        </p:nvSpPr>
-        <p:spPr>
-          <a:xfrm>
-            <a:off x="9720072" y="411480"/>
-            <a:ext cx="1920240" cy="384048"/>
-          </a:xfrm>
-          <a:prstGeom prst="roundRect">
-            <a:avLst>
-              <a:gd name="adj" fmla="val 50000"/>
-            </a:avLst>
-          </a:prstGeom>
-          <a:solidFill>
-            <a:schemeClr val="bg1"/>
-          </a:solidFill>
-          <a:ln w="12700">
-            <a:solidFill>
-              <a:schemeClr val="accent4"/>
-            </a:solidFill>
-          </a:ln>
-        </p:spPr>
-        <p:txBody>
-          <a:bodyPr wrap="square" lIns="0" tIns="0" rIns="0" bIns="0" rtlCol="0" anchor="ctr"/>
-          <a:lstStyle/>
-          <a:p>
-            <a:pPr marL="0" indent="0" algn="ctr">
-              <a:buNone/>
-            </a:pPr>
-            <a:r>
-              <a:rPr lang="en-US" sz="1300" b="1" dirty="0">
-                <a:solidFill>
-                  <a:schemeClr val="accent1"/>
-                </a:solidFill>
-                <a:latin typeface="Consolas" pitchFamily="34" charset="0"/>
-                <a:ea typeface="Consolas" pitchFamily="34" charset="-122"/>
-                <a:cs typeface="Consolas" pitchFamily="34" charset="-120"/>
-              </a:rPr>
-              <a:t>report/ §9</a:t>
-            </a:r>
-            <a:endParaRPr lang="en-US" sz="1300" dirty="0"/>
-          </a:p>
-        </p:txBody>
-      </p:sp>
-      <p:sp>
-        <p:nvSpPr>
-          <p:cNvPr id="5" name="a1_q_bg"/>
-          <p:cNvSpPr/>
-          <p:nvPr/>
-        </p:nvSpPr>
-        <p:spPr>
-          <a:xfrm>
-            <a:off x="548640" y="1645920"/>
-            <a:ext cx="11091672" cy="777240"/>
-          </a:xfrm>
-          <a:prstGeom prst="roundRect">
-            <a:avLst>
-              <a:gd name="adj" fmla="val 16471"/>
-            </a:avLst>
-          </a:prstGeom>
-          <a:solidFill>
-            <a:schemeClr val="bg1"/>
-          </a:solidFill>
-          <a:ln w="9525">
-            <a:solidFill>
-              <a:srgbClr val="DCE8DF"/>
-            </a:solidFill>
-            <a:prstDash val="solid"/>
-          </a:ln>
-          <a:effectLst>
-            <a:outerShdw blurRad="127000" dist="25400" dir="5400000" algn="bl" rotWithShape="0">
-              <a:srgbClr val="1B2A22">
-                <a:alpha val="14000"/>
-              </a:srgbClr>
-            </a:outerShdw>
-          </a:effectLst>
-        </p:spPr>
-        <p:txBody>
-          <a:bodyPr/>
-          <a:lstStyle/>
-          <a:p>
-            <a:endParaRPr lang="en-US"/>
-          </a:p>
-        </p:txBody>
-      </p:sp>
-      <p:sp>
-        <p:nvSpPr>
-          <p:cNvPr id="6" name="a1_q_tx"/>
-          <p:cNvSpPr txBox="1"/>
-          <p:nvPr/>
-        </p:nvSpPr>
-        <p:spPr>
-          <a:xfrm>
-            <a:off x="914400" y="1645920"/>
-            <a:ext cx="10360152" cy="777240"/>
-          </a:xfrm>
-          <a:prstGeom prst="rect">
-            <a:avLst/>
-          </a:prstGeom>
-          <a:noFill/>
-          <a:ln/>
-        </p:spPr>
-        <p:txBody>
-          <a:bodyPr wrap="square" lIns="0" tIns="0" rIns="0" bIns="0" rtlCol="0" anchor="ctr"/>
-          <a:lstStyle/>
-          <a:p>
-            <a:pPr marL="0" indent="0">
-              <a:buNone/>
-            </a:pPr>
-            <a:r>
-              <a:rPr lang="en-US" sz="2100" b="1" i="1" dirty="0">
-                <a:solidFill>
-                  <a:schemeClr val="tx2"/>
-                </a:solidFill>
-              </a:rPr>
-              <a:t>Is a model's score a property of the model, or of how we trained and tested it?</a:t>
-            </a:r>
-            <a:endParaRPr lang="en-US" sz="2100" dirty="0"/>
-          </a:p>
-        </p:txBody>
-      </p:sp>
-      <p:sp>
-        <p:nvSpPr>
-          <p:cNvPr id="7" name="a2_f"/>
-          <p:cNvSpPr/>
-          <p:nvPr/>
-        </p:nvSpPr>
-        <p:spPr>
-          <a:xfrm>
-            <a:off x="548640" y="2606040"/>
-            <a:ext cx="5440680" cy="2240280"/>
-          </a:xfrm>
-          <a:prstGeom prst="roundRect">
-            <a:avLst>
-              <a:gd name="adj" fmla="val 5714"/>
-            </a:avLst>
-          </a:prstGeom>
-          <a:solidFill>
-            <a:schemeClr val="bg1"/>
-          </a:solidFill>
-          <a:ln w="9525">
-            <a:solidFill>
-              <a:srgbClr val="DCE8DF"/>
-            </a:solidFill>
-            <a:prstDash val="solid"/>
-          </a:ln>
-          <a:effectLst>
-            <a:outerShdw blurRad="127000" dist="25400" dir="5400000" algn="bl" rotWithShape="0">
-              <a:srgbClr val="1B2A22">
-                <a:alpha val="14000"/>
-              </a:srgbClr>
-            </a:outerShdw>
-          </a:effectLst>
-        </p:spPr>
-        <p:txBody>
-          <a:bodyPr/>
-          <a:lstStyle/>
-          <a:p>
-            <a:endParaRPr lang="en-US"/>
-          </a:p>
-        </p:txBody>
-      </p:sp>
-      <p:sp>
-        <p:nvSpPr>
-          <p:cNvPr id="8" name="a2_fb_c"/>
-          <p:cNvSpPr/>
-          <p:nvPr/>
-        </p:nvSpPr>
-        <p:spPr>
-          <a:xfrm>
-            <a:off x="777240" y="2743200"/>
-            <a:ext cx="502920" cy="502920"/>
-          </a:xfrm>
-          <a:prstGeom prst="ellipse">
-            <a:avLst/>
-          </a:prstGeom>
-          <a:solidFill>
-            <a:schemeClr val="accent2"/>
-          </a:solidFill>
-          <a:ln/>
-          <a:effectLst>
-            <a:outerShdw blurRad="101600" dist="25400" dir="5400000" algn="bl" rotWithShape="0">
-              <a:srgbClr val="1B2A22">
-                <a:alpha val="18000"/>
-              </a:srgbClr>
-            </a:outerShdw>
-          </a:effectLst>
-        </p:spPr>
-        <p:txBody>
-          <a:bodyPr/>
-          <a:lstStyle/>
-          <a:p>
-            <a:endParaRPr lang="en-US"/>
-          </a:p>
-        </p:txBody>
-      </p:sp>
-      <p:pic>
-        <p:nvPicPr>
-          <p:cNvPr id="9" name="a2_fb_i" descr="preencoded.png"/>
-          <p:cNvPicPr>
-            <a:picLocks noChangeAspect="1"/>
-          </p:cNvPicPr>
-          <p:nvPr/>
-        </p:nvPicPr>
-        <p:blipFill>
-          <a:blip r:embed="rId3"/>
-          <a:stretch>
-            <a:fillRect/>
-          </a:stretch>
-        </p:blipFill>
-        <p:spPr>
-          <a:xfrm>
-            <a:off x="902970" y="2868930"/>
-            <a:ext cx="251460" cy="251460"/>
-          </a:xfrm>
-          <a:prstGeom prst="rect">
-            <a:avLst/>
-          </a:prstGeom>
-        </p:spPr>
-      </p:pic>
-      <p:sp>
-        <p:nvSpPr>
-          <p:cNvPr id="10" name="a2_fh"/>
-          <p:cNvSpPr txBox="1"/>
-          <p:nvPr/>
-        </p:nvSpPr>
-        <p:spPr>
-          <a:xfrm>
-            <a:off x="1417320" y="2743200"/>
-            <a:ext cx="4389120" cy="502920"/>
-          </a:xfrm>
-          <a:prstGeom prst="rect">
-            <a:avLst/>
-          </a:prstGeom>
-          <a:noFill/>
-          <a:ln/>
-        </p:spPr>
-        <p:txBody>
-          <a:bodyPr wrap="square" lIns="0" tIns="0" rIns="0" bIns="0" rtlCol="0" anchor="ctr"/>
-          <a:lstStyle/>
-          <a:p>
-            <a:pPr marL="0" indent="0">
-              <a:buNone/>
-            </a:pPr>
-            <a:r>
-              <a:rPr lang="en-US" sz="1800" b="1" dirty="0">
-                <a:solidFill>
-                  <a:schemeClr val="tx2"/>
-                </a:solidFill>
-              </a:rPr>
-              <a:t>What we found</a:t>
-            </a:r>
-            <a:endParaRPr lang="en-US" sz="1800" dirty="0"/>
-          </a:p>
-        </p:txBody>
-      </p:sp>
-      <p:sp>
-        <p:nvSpPr>
-          <p:cNvPr id="11" name="a3_ft_bul"/>
-          <p:cNvSpPr txBox="1"/>
-          <p:nvPr/>
-        </p:nvSpPr>
-        <p:spPr>
-          <a:xfrm>
-            <a:off x="822960" y="3383280"/>
-            <a:ext cx="4983480" cy="1371600"/>
-          </a:xfrm>
-          <a:prstGeom prst="rect">
-            <a:avLst/>
-          </a:prstGeom>
-          <a:noFill/>
-          <a:ln/>
-        </p:spPr>
-        <p:txBody>
-          <a:bodyPr wrap="square" lIns="0" tIns="0" rIns="0" bIns="0" rtlCol="0" anchor="t"/>
-          <a:lstStyle/>
-          <a:p>
-            <a:pPr marL="342900" indent="-342900">
-              <a:spcAft>
-                <a:spcPts val="600"/>
-              </a:spcAft>
-              <a:buSzPct val="100000"/>
-              <a:buChar char="•"/>
-            </a:pPr>
-            <a:r>
-              <a:rPr lang="en-US" sz="1500" dirty="0">
-                <a:solidFill>
-                  <a:schemeClr val="tx2"/>
-                </a:solidFill>
-              </a:rPr>
-              <a:t>TransE loses to a count: 0.339 vs 0.448</a:t>
-            </a:r>
-            <a:endParaRPr lang="en-US" sz="1500" dirty="0"/>
-          </a:p>
-          <a:p>
-            <a:pPr marL="342900" indent="-342900">
-              <a:spcAft>
-                <a:spcPts val="600"/>
-              </a:spcAft>
-              <a:buSzPct val="100000"/>
-              <a:buChar char="•"/>
-            </a:pPr>
-            <a:r>
-              <a:rPr lang="en-US" sz="1500" dirty="0">
-                <a:solidFill>
-                  <a:schemeClr val="tx2"/>
-                </a:solidFill>
-              </a:rPr>
-              <a:t>Tie handling changes the score by at most 0.001</a:t>
-            </a:r>
-            <a:endParaRPr lang="en-US" sz="1500" dirty="0"/>
-          </a:p>
-          <a:p>
-            <a:pPr marL="342900" indent="-342900">
-              <a:spcAft>
-                <a:spcPts val="600"/>
-              </a:spcAft>
-              <a:buSzPct val="100000"/>
-              <a:buChar char="•"/>
-            </a:pPr>
-            <a:r>
-              <a:rPr lang="en-US" sz="1500" dirty="0">
-                <a:solidFill>
-                  <a:schemeClr val="tx2"/>
-                </a:solidFill>
-              </a:rPr>
-              <a:t>TransE was never tuned: one setting only</a:t>
-            </a:r>
-            <a:endParaRPr lang="en-US" sz="1500" dirty="0"/>
-          </a:p>
-        </p:txBody>
-      </p:sp>
-      <p:sp>
-        <p:nvSpPr>
-          <p:cNvPr id="12" name="a4_p"/>
-          <p:cNvSpPr/>
-          <p:nvPr/>
-        </p:nvSpPr>
-        <p:spPr>
-          <a:xfrm>
-            <a:off x="6199632" y="2606040"/>
-            <a:ext cx="5440680" cy="2240280"/>
-          </a:xfrm>
-          <a:prstGeom prst="roundRect">
-            <a:avLst>
-              <a:gd name="adj" fmla="val 5714"/>
-            </a:avLst>
-          </a:prstGeom>
-          <a:solidFill>
-            <a:schemeClr val="accent1">
-              <a:alpha val="15000"/>
-            </a:schemeClr>
-          </a:solidFill>
-          <a:ln/>
-        </p:spPr>
-        <p:txBody>
-          <a:bodyPr/>
-          <a:lstStyle/>
-          <a:p>
-            <a:endParaRPr lang="en-US"/>
-          </a:p>
-        </p:txBody>
-      </p:sp>
-      <p:sp>
-        <p:nvSpPr>
-          <p:cNvPr id="13" name="a4_pb_c"/>
-          <p:cNvSpPr/>
-          <p:nvPr/>
-        </p:nvSpPr>
-        <p:spPr>
-          <a:xfrm>
-            <a:off x="6428232" y="2743200"/>
-            <a:ext cx="502920" cy="502920"/>
-          </a:xfrm>
-          <a:prstGeom prst="ellipse">
-            <a:avLst/>
-          </a:prstGeom>
-          <a:solidFill>
-            <a:schemeClr val="accent1"/>
-          </a:solidFill>
-          <a:ln/>
-          <a:effectLst>
-            <a:outerShdw blurRad="101600" dist="25400" dir="5400000" algn="bl" rotWithShape="0">
-              <a:srgbClr val="1B2A22">
-                <a:alpha val="18000"/>
-              </a:srgbClr>
-            </a:outerShdw>
-          </a:effectLst>
-        </p:spPr>
-        <p:txBody>
-          <a:bodyPr/>
-          <a:lstStyle/>
-          <a:p>
-            <a:endParaRPr lang="en-US"/>
-          </a:p>
-        </p:txBody>
-      </p:sp>
-      <p:pic>
-        <p:nvPicPr>
-          <p:cNvPr id="14" name="a4_pb_i" descr="preencoded.png"/>
-          <p:cNvPicPr>
-            <a:picLocks noChangeAspect="1"/>
-          </p:cNvPicPr>
-          <p:nvPr/>
-        </p:nvPicPr>
-        <p:blipFill>
-          <a:blip r:embed="rId4"/>
-          <a:stretch>
-            <a:fillRect/>
-          </a:stretch>
-        </p:blipFill>
-        <p:spPr>
-          <a:xfrm>
-            <a:off x="6553962" y="2868930"/>
-            <a:ext cx="251460" cy="251460"/>
-          </a:xfrm>
-          <a:prstGeom prst="rect">
-            <a:avLst/>
-          </a:prstGeom>
-        </p:spPr>
-      </p:pic>
-      <p:sp>
-        <p:nvSpPr>
-          <p:cNvPr id="15" name="a4_ph"/>
-          <p:cNvSpPr txBox="1"/>
-          <p:nvPr/>
-        </p:nvSpPr>
-        <p:spPr>
-          <a:xfrm>
-            <a:off x="7068312" y="2743200"/>
-            <a:ext cx="4389120" cy="502920"/>
-          </a:xfrm>
-          <a:prstGeom prst="rect">
-            <a:avLst/>
-          </a:prstGeom>
-          <a:noFill/>
-          <a:ln/>
-        </p:spPr>
-        <p:txBody>
-          <a:bodyPr wrap="square" lIns="0" tIns="0" rIns="0" bIns="0" rtlCol="0" anchor="ctr"/>
-          <a:lstStyle/>
-          <a:p>
-            <a:pPr marL="0" indent="0">
-              <a:buNone/>
-            </a:pPr>
-            <a:r>
-              <a:rPr lang="en-US" sz="1800" b="1" dirty="0">
-                <a:solidFill>
-                  <a:schemeClr val="tx2"/>
-                </a:solidFill>
-              </a:rPr>
-              <a:t>Our position</a:t>
-            </a:r>
-            <a:endParaRPr lang="en-US" sz="1800" dirty="0"/>
-          </a:p>
-        </p:txBody>
-      </p:sp>
-      <p:sp>
-        <p:nvSpPr>
-          <p:cNvPr id="16" name="a5_pt_bul"/>
-          <p:cNvSpPr txBox="1"/>
-          <p:nvPr/>
-        </p:nvSpPr>
-        <p:spPr>
-          <a:xfrm>
-            <a:off x="6473952" y="3383280"/>
-            <a:ext cx="4983480" cy="1371600"/>
-          </a:xfrm>
-          <a:prstGeom prst="rect">
-            <a:avLst/>
-          </a:prstGeom>
-          <a:noFill/>
-          <a:ln/>
-        </p:spPr>
-        <p:txBody>
-          <a:bodyPr wrap="square" lIns="0" tIns="0" rIns="0" bIns="0" rtlCol="0" anchor="t"/>
-          <a:lstStyle/>
-          <a:p>
-            <a:pPr marL="342900" indent="-342900">
-              <a:spcAft>
-                <a:spcPts val="600"/>
-              </a:spcAft>
-              <a:buSzPct val="100000"/>
-              <a:buChar char="•"/>
-            </a:pPr>
-            <a:r>
-              <a:rPr lang="en-US" sz="1500" dirty="0">
-                <a:solidFill>
-                  <a:schemeClr val="tx2"/>
-                </a:solidFill>
-              </a:rPr>
-              <a:t>Same tuning budget for model and baseline</a:t>
-            </a:r>
-            <a:endParaRPr lang="en-US" sz="1500" dirty="0"/>
-          </a:p>
-          <a:p>
-            <a:pPr marL="342900" indent="-342900">
-              <a:spcAft>
-                <a:spcPts val="600"/>
-              </a:spcAft>
-              <a:buSzPct val="100000"/>
-              <a:buChar char="•"/>
-            </a:pPr>
-            <a:r>
-              <a:rPr lang="en-US" sz="1500" dirty="0">
-                <a:solidFill>
-                  <a:schemeClr val="tx2"/>
-                </a:solidFill>
-              </a:rPr>
-              <a:t>State the test protocol, ties included</a:t>
-            </a:r>
-            <a:endParaRPr lang="en-US" sz="1500" dirty="0"/>
-          </a:p>
-          <a:p>
-            <a:pPr marL="342900" indent="-342900">
-              <a:spcAft>
-                <a:spcPts val="600"/>
-              </a:spcAft>
-              <a:buSzPct val="100000"/>
-              <a:buChar char="•"/>
-            </a:pPr>
-            <a:r>
-              <a:rPr lang="en-US" sz="1500" dirty="0">
-                <a:solidFill>
-                  <a:schemeClr val="tx2"/>
-                </a:solidFill>
-              </a:rPr>
-              <a:t>The gap must be bigger than the seed spread</a:t>
-            </a:r>
-            <a:endParaRPr lang="en-US" sz="1500" dirty="0"/>
-          </a:p>
-          <a:p>
-            <a:pPr marL="342900" indent="-342900">
-              <a:spcAft>
-                <a:spcPts val="600"/>
-              </a:spcAft>
-              <a:buSzPct val="100000"/>
-              <a:buChar char="•"/>
-            </a:pPr>
-            <a:r>
-              <a:rPr lang="en-US" sz="1500" dirty="0">
-                <a:solidFill>
-                  <a:schemeClr val="tx2"/>
-                </a:solidFill>
-              </a:rPr>
-              <a:t>Until then: no predictions shown as facts</a:t>
-            </a:r>
-            <a:endParaRPr lang="en-US" sz="1500" dirty="0"/>
-          </a:p>
-        </p:txBody>
-      </p:sp>
-      <p:pic>
-        <p:nvPicPr>
-          <p:cNvPr id="17" name="a6_desc_bg" descr="preencoded.png"/>
-          <p:cNvPicPr>
-            <a:picLocks noChangeAspect="1"/>
-          </p:cNvPicPr>
-          <p:nvPr/>
-        </p:nvPicPr>
-        <p:blipFill>
-          <a:blip r:embed="rId5"/>
-          <a:stretch>
-            <a:fillRect/>
-          </a:stretch>
-        </p:blipFill>
-        <p:spPr>
-          <a:xfrm>
-            <a:off x="548640" y="5029200"/>
-            <a:ext cx="11091672" cy="1261872"/>
-          </a:xfrm>
-          <a:prstGeom prst="rect">
-            <a:avLst/>
-          </a:prstGeom>
-          <a:effectLst>
-            <a:outerShdw blurRad="152400" dist="25400" dir="5400000" algn="bl" rotWithShape="0">
-              <a:srgbClr val="1B2A22">
-                <a:alpha val="25000"/>
-              </a:srgbClr>
-            </a:outerShdw>
-          </a:effectLst>
-        </p:spPr>
-      </p:pic>
-      <p:sp>
-        <p:nvSpPr>
-          <p:cNvPr id="18" name="a6_desc_tx"/>
-          <p:cNvSpPr txBox="1"/>
-          <p:nvPr/>
-        </p:nvSpPr>
-        <p:spPr>
-          <a:xfrm>
-            <a:off x="914400" y="5029200"/>
-            <a:ext cx="10360152" cy="1261872"/>
-          </a:xfrm>
-          <a:prstGeom prst="rect">
-            <a:avLst/>
-          </a:prstGeom>
-          <a:noFill/>
-          <a:ln/>
-        </p:spPr>
-        <p:txBody>
-          <a:bodyPr wrap="square" lIns="0" tIns="0" rIns="0" bIns="0" rtlCol="0" anchor="ctr"/>
-          <a:lstStyle/>
-          <a:p>
-            <a:pPr marL="0" indent="0">
-              <a:lnSpc>
-                <a:spcPct val="100000"/>
-              </a:lnSpc>
-              <a:buNone/>
-            </a:pPr>
-            <a:r>
-              <a:rPr lang="en-US" sz="1400" dirty="0">
-                <a:solidFill>
-                  <a:schemeClr val="bg1"/>
-                </a:solidFill>
-              </a:rPr>
-              <a:t>Our TransE lost to a simple count. The literature (Kadlec </a:t>
-            </a:r>
-            <a:r>
-              <a:rPr lang="en-US" sz="1400" b="1" dirty="0">
-                <a:solidFill>
-                  <a:schemeClr val="accent6"/>
-                </a:solidFill>
-              </a:rPr>
-              <a:t>2017</a:t>
-            </a:r>
-            <a:r>
-              <a:rPr lang="en-US" sz="1400" dirty="0">
-                <a:solidFill>
-                  <a:schemeClr val="bg1"/>
-                </a:solidFill>
-              </a:rPr>
-              <a:t>, Ruffinelli </a:t>
-            </a:r>
-            <a:r>
-              <a:rPr lang="en-US" sz="1400" b="1" dirty="0">
-                <a:solidFill>
-                  <a:schemeClr val="accent6"/>
-                </a:solidFill>
-              </a:rPr>
-              <a:t>2020</a:t>
-            </a:r>
-            <a:r>
-              <a:rPr lang="en-US" sz="1400" dirty="0">
-                <a:solidFill>
-                  <a:schemeClr val="bg1"/>
-                </a:solidFill>
-              </a:rPr>
-              <a:t>, Sun </a:t>
-            </a:r>
-            <a:r>
-              <a:rPr lang="en-US" sz="1400" b="1" dirty="0">
-                <a:solidFill>
-                  <a:schemeClr val="accent6"/>
-                </a:solidFill>
-              </a:rPr>
-              <a:t>2020</a:t>
-            </a:r>
-            <a:r>
-              <a:rPr lang="en-US" sz="1400" dirty="0">
-                <a:solidFill>
-                  <a:schemeClr val="bg1"/>
-                </a:solidFill>
-              </a:rPr>
-              <a:t>, Ali </a:t>
-            </a:r>
-            <a:r>
-              <a:rPr lang="en-US" sz="1400" b="1" dirty="0">
-                <a:solidFill>
-                  <a:schemeClr val="accent6"/>
-                </a:solidFill>
-              </a:rPr>
-              <a:t>2022</a:t>
-            </a:r>
-            <a:r>
-              <a:rPr lang="en-US" sz="1400" dirty="0">
-                <a:solidFill>
-                  <a:schemeClr val="bg1"/>
-                </a:solidFill>
-              </a:rPr>
-              <a:t>) shows that many reported gains vanish with fair tuning or a fair way to break ties. We checked ties on our own run: they change the score by at most </a:t>
-            </a:r>
-            <a:r>
-              <a:rPr lang="en-US" sz="1400" b="1" dirty="0">
-                <a:solidFill>
-                  <a:schemeClr val="accent6"/>
-                </a:solidFill>
-              </a:rPr>
-              <a:t>0.001</a:t>
-            </a:r>
-            <a:r>
-              <a:rPr lang="en-US" sz="1400" dirty="0">
-                <a:solidFill>
-                  <a:schemeClr val="bg1"/>
-                </a:solidFill>
-              </a:rPr>
-              <a:t>. But we never tuned TransE. So a model beats a baseline only with the same tuning budget, a stated protocol and a gap bigger than the seed spread.</a:t>
-            </a:r>
-            <a:endParaRPr lang="en-US" sz="1400" dirty="0"/>
-          </a:p>
-        </p:txBody>
-      </p:sp>
-      <p:sp>
-        <p:nvSpPr>
-          <p:cNvPr id="19" name="Slide Number Placeholder 0"/>
-          <p:cNvSpPr>
-            <a:spLocks noGrp="1"/>
-          </p:cNvSpPr>
-          <p:nvPr>
-            <p:ph type="sldNum" sz="quarter" idx="4294967295"/>
-          </p:nvPr>
-        </p:nvSpPr>
-        <p:spPr>
-          <a:xfrm>
-            <a:off x="11183112" y="6446520"/>
-            <a:ext cx="457200" cy="256032"/>
-          </a:xfrm>
-          <a:prstGeom prst="rect">
-            <a:avLst/>
-          </a:prstGeom>
-          <a:extLst>
-            <a:ext uri="{C572A759-6A51-4108-AA02-DFA0A04FC94B}">
-              <ma14:wrappingTextBoxFlag xmlns:ma14="http://schemas.microsoft.com/office/mac/drawingml/2011/main" xmlns="" val="0"/>
-            </a:ext>
-          </a:extLst>
-        </p:spPr>
-        <p:txBody>
-          <a:bodyPr/>
-          <a:lstStyle>
-            <a:lvl1pPr>
-              <a:defRPr sz="1000">
-                <a:solidFill>
-                  <a:schemeClr val="accent5"/>
-                </a:solidFill>
-              </a:defRPr>
-            </a:lvl1pPr>
-          </a:lstStyle>
-          <a:p>
-            <a:pPr algn="r"/>
-            <a:fld id="{F7021451-1387-4CA6-816F-3879F97B5CBC}" type="slidenum">
-              <a:rPr lang="en-US" b="0"/>
-              <a:t>11</a:t>
-            </a:fld>
-            <a:endParaRPr lang="en-US"/>
-          </a:p>
-        </p:txBody>
-      </p:sp>
-    </p:spTree>
-  </p:cSld>
-  <p:clrMapOvr>
-    <a:masterClrMapping/>
-  </p:clrMapOvr>
-  <mc:AlternateContent xmlns:mc="http://schemas.openxmlformats.org/markup-compatibility/2006" xmlns:p159="http://schemas.microsoft.com/office/powerpoint/2015/09/main">
-    <mc:Choice Requires="p159">
-      <p:transition spd="slow">
-        <p159:morph option="byObject"/>
-      </p:transition>
-    </mc:Choice>
-    <mc:Fallback xmlns="">
-      <p:transition spd="slow">
-        <p:fade/>
-      </p:transition>
-    </mc:Fallback>
-  </mc:AlternateContent>
-  <p:timing>
-    <p:tnLst>
-      <p:par>
-        <p:cTn id="1" dur="indefinite" restart="never" nodeType="tmRoot">
-          <p:childTnLst>
-            <p:seq concurrent="1" nextAc="seek">
-              <p:cTn id="2" dur="indefinite" nodeType="mainSeq">
-                <p:childTnLst>
-                  <p:par>
-                    <p:cTn id="3" fill="hold">
-                      <p:stCondLst>
-                        <p:cond delay="indefinite"/>
-                        <p:cond evt="onBegin" delay="0">
-                          <p:tn val="2"/>
-                        </p:cond>
-                      </p:stCondLst>
-                      <p:childTnLst>
-                        <p:par>
-                          <p:cTn id="4" fill="hold">
-                            <p:stCondLst>
-                              <p:cond delay="0"/>
-                            </p:stCondLst>
-                            <p:childTnLst>
-                              <p:par>
-                                <p:cTn id="5" presetID="10" presetClass="entr" presetSubtype="0" fill="hold" grpId="0" nodeType="afterEffect">
-                                  <p:stCondLst>
-                                    <p:cond delay="0"/>
-                                  </p:stCondLst>
-                                  <p:childTnLst>
-                                    <p:set>
-                                      <p:cBhvr>
-                                        <p:cTn id="6" dur="1" fill="hold">
-                                          <p:stCondLst>
-                                            <p:cond delay="0"/>
-                                          </p:stCondLst>
-                                        </p:cTn>
-                                        <p:tgtEl>
-                                          <p:spTgt spid="3"/>
-                                        </p:tgtEl>
-                                        <p:attrNameLst>
-                                          <p:attrName>style.visibility</p:attrName>
-                                        </p:attrNameLst>
-                                      </p:cBhvr>
-                                      <p:to>
-                                        <p:strVal val="visible"/>
-                                      </p:to>
-                                    </p:set>
-                                    <p:animEffect transition="in" filter="fade">
-                                      <p:cBhvr>
-                                        <p:cTn id="7" dur="500"/>
-                                        <p:tgtEl>
-                                          <p:spTgt spid="3"/>
-                                        </p:tgtEl>
-                                      </p:cBhvr>
-                                    </p:animEffect>
-                                  </p:childTnLst>
-                                </p:cTn>
-                              </p:par>
-                              <p:par>
-                                <p:cTn id="8" presetID="22" presetClass="entr" presetSubtype="8" fill="hold" grpId="0" nodeType="withEffect">
-                                  <p:stCondLst>
-                                    <p:cond delay="0"/>
-                                  </p:stCondLst>
-                                  <p:childTnLst>
-                                    <p:set>
-                                      <p:cBhvr>
-                                        <p:cTn id="9" dur="1" fill="hold">
-                                          <p:stCondLst>
-                                            <p:cond delay="0"/>
-                                          </p:stCondLst>
-                                        </p:cTn>
-                                        <p:tgtEl>
-                                          <p:spTgt spid="4"/>
-                                        </p:tgtEl>
-                                        <p:attrNameLst>
-                                          <p:attrName>style.visibility</p:attrName>
-                                        </p:attrNameLst>
-                                      </p:cBhvr>
-                                      <p:to>
-                                        <p:strVal val="visible"/>
-                                      </p:to>
-                                    </p:set>
-                                    <p:animEffect transition="in" filter="wipe(left)">
-                                      <p:cBhvr>
-                                        <p:cTn id="10" dur="600"/>
-                                        <p:tgtEl>
-                                          <p:spTgt spid="4"/>
-                                        </p:tgtEl>
-                                      </p:cBhvr>
-                                    </p:animEffect>
-                                  </p:childTnLst>
-                                </p:cTn>
-                              </p:par>
-                            </p:childTnLst>
-                          </p:cTn>
-                        </p:par>
-                      </p:childTnLst>
-                    </p:cTn>
-                  </p:par>
-                  <p:par>
-                    <p:cTn id="11" fill="hold">
-                      <p:stCondLst>
-                        <p:cond delay="indefinite"/>
-                      </p:stCondLst>
-                      <p:childTnLst>
-                        <p:par>
-                          <p:cTn id="12" fill="hold">
-                            <p:stCondLst>
-                              <p:cond delay="0"/>
-                            </p:stCondLst>
-                            <p:childTnLst>
-                              <p:par>
-                                <p:cTn id="13" presetID="22" presetClass="entr" presetSubtype="8" fill="hold" grpId="0" nodeType="clickEffect">
-                                  <p:stCondLst>
-                                    <p:cond delay="0"/>
-                                  </p:stCondLst>
-                                  <p:childTnLst>
-                                    <p:set>
-                                      <p:cBhvr>
-                                        <p:cTn id="14" dur="1" fill="hold">
-                                          <p:stCondLst>
-                                            <p:cond delay="0"/>
-                                          </p:stCondLst>
-                                        </p:cTn>
-                                        <p:tgtEl>
-                                          <p:spTgt spid="5"/>
-                                        </p:tgtEl>
-                                        <p:attrNameLst>
-                                          <p:attrName>style.visibility</p:attrName>
-                                        </p:attrNameLst>
-                                      </p:cBhvr>
-                                      <p:to>
-                                        <p:strVal val="visible"/>
-                                      </p:to>
-                                    </p:set>
-                                    <p:animEffect transition="in" filter="wipe(left)">
-                                      <p:cBhvr>
-                                        <p:cTn id="15" dur="600"/>
-                                        <p:tgtEl>
-                                          <p:spTgt spid="5"/>
-                                        </p:tgtEl>
-                                      </p:cBhvr>
-                                    </p:animEffect>
-                                  </p:childTnLst>
-                                </p:cTn>
-                              </p:par>
-                              <p:par>
-                                <p:cTn id="16" presetID="10" presetClass="entr" presetSubtype="0" fill="hold" grpId="0" nodeType="withEffect">
-                                  <p:stCondLst>
-                                    <p:cond delay="0"/>
-                                  </p:stCondLst>
-                                  <p:childTnLst>
-                                    <p:set>
-                                      <p:cBhvr>
-                                        <p:cTn id="17" dur="1" fill="hold">
-                                          <p:stCondLst>
-                                            <p:cond delay="0"/>
-                                          </p:stCondLst>
-                                        </p:cTn>
-                                        <p:tgtEl>
-                                          <p:spTgt spid="6"/>
-                                        </p:tgtEl>
-                                        <p:attrNameLst>
-                                          <p:attrName>style.visibility</p:attrName>
-                                        </p:attrNameLst>
-                                      </p:cBhvr>
-                                      <p:to>
-                                        <p:strVal val="visible"/>
-                                      </p:to>
-                                    </p:set>
-                                    <p:animEffect transition="in" filter="fade">
-                                      <p:cBhvr>
-                                        <p:cTn id="18" dur="500"/>
-                                        <p:tgtEl>
-                                          <p:spTgt spid="6"/>
-                                        </p:tgtEl>
-                                      </p:cBhvr>
-                                    </p:animEffect>
-                                  </p:childTnLst>
-                                </p:cTn>
-                              </p:par>
-                            </p:childTnLst>
-                          </p:cTn>
-                        </p:par>
-                      </p:childTnLst>
-                    </p:cTn>
-                  </p:par>
-                  <p:par>
-                    <p:cTn id="19" fill="hold">
-                      <p:stCondLst>
-                        <p:cond delay="indefinite"/>
-                      </p:stCondLst>
-                      <p:childTnLst>
-                        <p:par>
-                          <p:cTn id="20" fill="hold">
-                            <p:stCondLst>
-                              <p:cond delay="0"/>
-                            </p:stCondLst>
-                            <p:childTnLst>
-                              <p:par>
-                                <p:cTn id="21" presetID="22" presetClass="entr" presetSubtype="8" fill="hold" grpId="0" nodeType="clickEffect">
-                                  <p:stCondLst>
-                                    <p:cond delay="0"/>
-                                  </p:stCondLst>
-                                  <p:childTnLst>
-                                    <p:set>
-                                      <p:cBhvr>
-                                        <p:cTn id="22" dur="1" fill="hold">
-                                          <p:stCondLst>
-                                            <p:cond delay="0"/>
-                                          </p:stCondLst>
-                                        </p:cTn>
-                                        <p:tgtEl>
-                                          <p:spTgt spid="7"/>
-                                        </p:tgtEl>
-                                        <p:attrNameLst>
-                                          <p:attrName>style.visibility</p:attrName>
-                                        </p:attrNameLst>
-                                      </p:cBhvr>
-                                      <p:to>
-                                        <p:strVal val="visible"/>
-                                      </p:to>
-                                    </p:set>
-                                    <p:animEffect transition="in" filter="wipe(left)">
-                                      <p:cBhvr>
-                                        <p:cTn id="23" dur="600"/>
-                                        <p:tgtEl>
-                                          <p:spTgt spid="7"/>
-                                        </p:tgtEl>
-                                      </p:cBhvr>
-                                    </p:animEffect>
-                                  </p:childTnLst>
-                                </p:cTn>
-                              </p:par>
-                              <p:par>
-                                <p:cTn id="24" presetID="10" presetClass="entr" presetSubtype="0" fill="hold" grpId="0" nodeType="withEffect">
-                                  <p:stCondLst>
-                                    <p:cond delay="0"/>
-                                  </p:stCondLst>
-                                  <p:childTnLst>
-                                    <p:set>
-                                      <p:cBhvr>
-                                        <p:cTn id="25" dur="1" fill="hold">
-                                          <p:stCondLst>
-                                            <p:cond delay="0"/>
-                                          </p:stCondLst>
-                                        </p:cTn>
-                                        <p:tgtEl>
-                                          <p:spTgt spid="8"/>
-                                        </p:tgtEl>
-                                        <p:attrNameLst>
-                                          <p:attrName>style.visibility</p:attrName>
-                                        </p:attrNameLst>
-                                      </p:cBhvr>
-                                      <p:to>
-                                        <p:strVal val="visible"/>
-                                      </p:to>
-                                    </p:set>
-                                    <p:animEffect transition="in" filter="fade">
-                                      <p:cBhvr>
-                                        <p:cTn id="26" dur="500"/>
-                                        <p:tgtEl>
-                                          <p:spTgt spid="8"/>
-                                        </p:tgtEl>
-                                      </p:cBhvr>
-                                    </p:animEffect>
-                                  </p:childTnLst>
-                                </p:cTn>
-                              </p:par>
-                              <p:par>
-                                <p:cTn id="27" presetID="10" presetClass="entr" presetSubtype="0" fill="hold" nodeType="withEffect">
-                                  <p:stCondLst>
-                                    <p:cond delay="0"/>
-                                  </p:stCondLst>
-                                  <p:childTnLst>
-                                    <p:set>
-                                      <p:cBhvr>
-                                        <p:cTn id="28" dur="1" fill="hold">
-                                          <p:stCondLst>
-                                            <p:cond delay="0"/>
-                                          </p:stCondLst>
-                                        </p:cTn>
-                                        <p:tgtEl>
-                                          <p:spTgt spid="9"/>
-                                        </p:tgtEl>
-                                        <p:attrNameLst>
-                                          <p:attrName>style.visibility</p:attrName>
-                                        </p:attrNameLst>
-                                      </p:cBhvr>
-                                      <p:to>
-                                        <p:strVal val="visible"/>
-                                      </p:to>
-                                    </p:set>
-                                    <p:animEffect transition="in" filter="fade">
-                                      <p:cBhvr>
-                                        <p:cTn id="29" dur="500"/>
-                                        <p:tgtEl>
-                                          <p:spTgt spid="9"/>
-                                        </p:tgtEl>
-                                      </p:cBhvr>
-                                    </p:animEffect>
-                                  </p:childTnLst>
-                                </p:cTn>
-                              </p:par>
-                              <p:par>
-                                <p:cTn id="30" presetID="10" presetClass="entr" presetSubtype="0" fill="hold" grpId="0" nodeType="withEffect">
-                                  <p:stCondLst>
-                                    <p:cond delay="0"/>
-                                  </p:stCondLst>
-                                  <p:childTnLst>
-                                    <p:set>
-                                      <p:cBhvr>
-                                        <p:cTn id="31" dur="1" fill="hold">
-                                          <p:stCondLst>
-                                            <p:cond delay="0"/>
-                                          </p:stCondLst>
-                                        </p:cTn>
-                                        <p:tgtEl>
-                                          <p:spTgt spid="10"/>
-                                        </p:tgtEl>
-                                        <p:attrNameLst>
-                                          <p:attrName>style.visibility</p:attrName>
-                                        </p:attrNameLst>
-                                      </p:cBhvr>
-                                      <p:to>
-                                        <p:strVal val="visible"/>
-                                      </p:to>
-                                    </p:set>
-                                    <p:animEffect transition="in" filter="fade">
-                                      <p:cBhvr>
-                                        <p:cTn id="32" dur="500"/>
-                                        <p:tgtEl>
-                                          <p:spTgt spid="10"/>
-                                        </p:tgtEl>
-                                      </p:cBhvr>
-                                    </p:animEffect>
-                                  </p:childTnLst>
-                                </p:cTn>
-                              </p:par>
-                            </p:childTnLst>
-                          </p:cTn>
-                        </p:par>
-                        <p:par>
-                          <p:cTn id="33" fill="hold">
-                            <p:stCondLst>
-                              <p:cond delay="280"/>
-                            </p:stCondLst>
-                            <p:childTnLst>
-                              <p:par>
-                                <p:cTn id="34" presetID="10" presetClass="entr" presetSubtype="0" fill="hold" grpId="0" nodeType="afterEffect">
-                                  <p:stCondLst>
-                                    <p:cond delay="0"/>
-                                  </p:stCondLst>
-                                  <p:childTnLst>
-                                    <p:set>
-                                      <p:cBhvr>
-                                        <p:cTn id="35" dur="1" fill="hold">
-                                          <p:stCondLst>
-                                            <p:cond delay="0"/>
-                                          </p:stCondLst>
-                                        </p:cTn>
-                                        <p:tgtEl>
-                                          <p:spTgt spid="11">
-                                            <p:txEl>
-                                              <p:pRg st="0" end="0"/>
-                                            </p:txEl>
-                                          </p:spTgt>
-                                        </p:tgtEl>
-                                        <p:attrNameLst>
-                                          <p:attrName>style.visibility</p:attrName>
-                                        </p:attrNameLst>
-                                      </p:cBhvr>
-                                      <p:to>
-                                        <p:strVal val="visible"/>
-                                      </p:to>
-                                    </p:set>
-                                    <p:animEffect transition="in" filter="fade">
-                                      <p:cBhvr>
-                                        <p:cTn id="36" dur="500"/>
-                                        <p:tgtEl>
-                                          <p:spTgt spid="11">
-                                            <p:txEl>
-                                              <p:pRg st="0" end="0"/>
-                                            </p:txEl>
-                                          </p:spTgt>
-                                        </p:tgtEl>
-                                      </p:cBhvr>
-                                    </p:animEffect>
-                                  </p:childTnLst>
-                                </p:cTn>
-                              </p:par>
-                            </p:childTnLst>
-                          </p:cTn>
-                        </p:par>
-                        <p:par>
-                          <p:cTn id="37" fill="hold">
-                            <p:stCondLst>
-                              <p:cond delay="560"/>
-                            </p:stCondLst>
-                            <p:childTnLst>
-                              <p:par>
-                                <p:cTn id="38" presetID="10" presetClass="entr" presetSubtype="0" fill="hold" grpId="0" nodeType="afterEffect">
-                                  <p:stCondLst>
-                                    <p:cond delay="0"/>
-                                  </p:stCondLst>
-                                  <p:childTnLst>
-                                    <p:set>
-                                      <p:cBhvr>
-                                        <p:cTn id="39" dur="1" fill="hold">
-                                          <p:stCondLst>
-                                            <p:cond delay="0"/>
-                                          </p:stCondLst>
-                                        </p:cTn>
-                                        <p:tgtEl>
-                                          <p:spTgt spid="11">
-                                            <p:txEl>
-                                              <p:pRg st="1" end="1"/>
-                                            </p:txEl>
-                                          </p:spTgt>
-                                        </p:tgtEl>
-                                        <p:attrNameLst>
-                                          <p:attrName>style.visibility</p:attrName>
-                                        </p:attrNameLst>
-                                      </p:cBhvr>
-                                      <p:to>
-                                        <p:strVal val="visible"/>
-                                      </p:to>
-                                    </p:set>
-                                    <p:animEffect transition="in" filter="fade">
-                                      <p:cBhvr>
-                                        <p:cTn id="40" dur="500"/>
-                                        <p:tgtEl>
-                                          <p:spTgt spid="11">
-                                            <p:txEl>
-                                              <p:pRg st="1" end="1"/>
-                                            </p:txEl>
-                                          </p:spTgt>
-                                        </p:tgtEl>
-                                      </p:cBhvr>
-                                    </p:animEffect>
-                                  </p:childTnLst>
-                                </p:cTn>
-                              </p:par>
-                            </p:childTnLst>
-                          </p:cTn>
-                        </p:par>
-                        <p:par>
-                          <p:cTn id="41" fill="hold">
-                            <p:stCondLst>
-                              <p:cond delay="840"/>
-                            </p:stCondLst>
-                            <p:childTnLst>
-                              <p:par>
-                                <p:cTn id="42" presetID="10" presetClass="entr" presetSubtype="0" fill="hold" grpId="0" nodeType="afterEffect">
-                                  <p:stCondLst>
-                                    <p:cond delay="0"/>
-                                  </p:stCondLst>
-                                  <p:childTnLst>
-                                    <p:set>
-                                      <p:cBhvr>
-                                        <p:cTn id="43" dur="1" fill="hold">
-                                          <p:stCondLst>
-                                            <p:cond delay="0"/>
-                                          </p:stCondLst>
-                                        </p:cTn>
-                                        <p:tgtEl>
-                                          <p:spTgt spid="11">
-                                            <p:txEl>
-                                              <p:pRg st="2" end="2"/>
-                                            </p:txEl>
-                                          </p:spTgt>
-                                        </p:tgtEl>
-                                        <p:attrNameLst>
-                                          <p:attrName>style.visibility</p:attrName>
-                                        </p:attrNameLst>
-                                      </p:cBhvr>
-                                      <p:to>
-                                        <p:strVal val="visible"/>
-                                      </p:to>
-                                    </p:set>
-                                    <p:animEffect transition="in" filter="fade">
-                                      <p:cBhvr>
-                                        <p:cTn id="44" dur="500"/>
-                                        <p:tgtEl>
-                                          <p:spTgt spid="11">
-                                            <p:txEl>
-                                              <p:pRg st="2" end="2"/>
-                                            </p:txEl>
-                                          </p:spTgt>
-                                        </p:tgtEl>
-                                      </p:cBhvr>
-                                    </p:animEffect>
-                                  </p:childTnLst>
-                                </p:cTn>
-                              </p:par>
-                            </p:childTnLst>
-                          </p:cTn>
-                        </p:par>
-                      </p:childTnLst>
-                    </p:cTn>
-                  </p:par>
-                  <p:par>
-                    <p:cTn id="45" fill="hold">
-                      <p:stCondLst>
-                        <p:cond delay="indefinite"/>
-                      </p:stCondLst>
-                      <p:childTnLst>
-                        <p:par>
-                          <p:cTn id="46" fill="hold">
-                            <p:stCondLst>
-                              <p:cond delay="0"/>
-                            </p:stCondLst>
-                            <p:childTnLst>
-                              <p:par>
-                                <p:cTn id="47" presetID="22" presetClass="entr" presetSubtype="8" fill="hold" grpId="0" nodeType="clickEffect">
-                                  <p:stCondLst>
-                                    <p:cond delay="0"/>
-                                  </p:stCondLst>
-                                  <p:childTnLst>
-                                    <p:set>
-                                      <p:cBhvr>
-                                        <p:cTn id="48" dur="1" fill="hold">
-                                          <p:stCondLst>
-                                            <p:cond delay="0"/>
-                                          </p:stCondLst>
-                                        </p:cTn>
-                                        <p:tgtEl>
-                                          <p:spTgt spid="12"/>
-                                        </p:tgtEl>
-                                        <p:attrNameLst>
-                                          <p:attrName>style.visibility</p:attrName>
-                                        </p:attrNameLst>
-                                      </p:cBhvr>
-                                      <p:to>
-                                        <p:strVal val="visible"/>
-                                      </p:to>
-                                    </p:set>
-                                    <p:animEffect transition="in" filter="wipe(left)">
-                                      <p:cBhvr>
-                                        <p:cTn id="49" dur="600"/>
-                                        <p:tgtEl>
-                                          <p:spTgt spid="12"/>
-                                        </p:tgtEl>
-                                      </p:cBhvr>
-                                    </p:animEffect>
-                                  </p:childTnLst>
-                                </p:cTn>
-                              </p:par>
-                              <p:par>
-                                <p:cTn id="50" presetID="10" presetClass="entr" presetSubtype="0" fill="hold" grpId="0" nodeType="withEffect">
-                                  <p:stCondLst>
-                                    <p:cond delay="0"/>
-                                  </p:stCondLst>
-                                  <p:childTnLst>
-                                    <p:set>
-                                      <p:cBhvr>
-                                        <p:cTn id="51" dur="1" fill="hold">
-                                          <p:stCondLst>
-                                            <p:cond delay="0"/>
-                                          </p:stCondLst>
-                                        </p:cTn>
-                                        <p:tgtEl>
-                                          <p:spTgt spid="13"/>
-                                        </p:tgtEl>
-                                        <p:attrNameLst>
-                                          <p:attrName>style.visibility</p:attrName>
-                                        </p:attrNameLst>
-                                      </p:cBhvr>
-                                      <p:to>
-                                        <p:strVal val="visible"/>
-                                      </p:to>
-                                    </p:set>
-                                    <p:animEffect transition="in" filter="fade">
-                                      <p:cBhvr>
-                                        <p:cTn id="52" dur="500"/>
-                                        <p:tgtEl>
-                                          <p:spTgt spid="13"/>
-                                        </p:tgtEl>
-                                      </p:cBhvr>
-                                    </p:animEffect>
-                                  </p:childTnLst>
-                                </p:cTn>
-                              </p:par>
-                              <p:par>
-                                <p:cTn id="53" presetID="10" presetClass="entr" presetSubtype="0" fill="hold" nodeType="withEffect">
-                                  <p:stCondLst>
-                                    <p:cond delay="0"/>
-                                  </p:stCondLst>
-                                  <p:childTnLst>
-                                    <p:set>
-                                      <p:cBhvr>
-                                        <p:cTn id="54" dur="1" fill="hold">
-                                          <p:stCondLst>
-                                            <p:cond delay="0"/>
-                                          </p:stCondLst>
-                                        </p:cTn>
-                                        <p:tgtEl>
-                                          <p:spTgt spid="14"/>
-                                        </p:tgtEl>
-                                        <p:attrNameLst>
-                                          <p:attrName>style.visibility</p:attrName>
-                                        </p:attrNameLst>
-                                      </p:cBhvr>
-                                      <p:to>
-                                        <p:strVal val="visible"/>
-                                      </p:to>
-                                    </p:set>
-                                    <p:animEffect transition="in" filter="fade">
-                                      <p:cBhvr>
-                                        <p:cTn id="55" dur="500"/>
-                                        <p:tgtEl>
-                                          <p:spTgt spid="14"/>
-                                        </p:tgtEl>
-                                      </p:cBhvr>
-                                    </p:animEffect>
-                                  </p:childTnLst>
-                                </p:cTn>
-                              </p:par>
-                              <p:par>
-                                <p:cTn id="56" presetID="10" presetClass="entr" presetSubtype="0" fill="hold" grpId="0" nodeType="withEffect">
-                                  <p:stCondLst>
-                                    <p:cond delay="0"/>
-                                  </p:stCondLst>
-                                  <p:childTnLst>
-                                    <p:set>
-                                      <p:cBhvr>
-                                        <p:cTn id="57" dur="1" fill="hold">
-                                          <p:stCondLst>
-                                            <p:cond delay="0"/>
-                                          </p:stCondLst>
-                                        </p:cTn>
-                                        <p:tgtEl>
-                                          <p:spTgt spid="15"/>
-                                        </p:tgtEl>
-                                        <p:attrNameLst>
-                                          <p:attrName>style.visibility</p:attrName>
-                                        </p:attrNameLst>
-                                      </p:cBhvr>
-                                      <p:to>
-                                        <p:strVal val="visible"/>
-                                      </p:to>
-                                    </p:set>
-                                    <p:animEffect transition="in" filter="fade">
-                                      <p:cBhvr>
-                                        <p:cTn id="58" dur="500"/>
-                                        <p:tgtEl>
-                                          <p:spTgt spid="15"/>
-                                        </p:tgtEl>
-                                      </p:cBhvr>
-                                    </p:animEffect>
-                                  </p:childTnLst>
-                                </p:cTn>
-                              </p:par>
-                            </p:childTnLst>
-                          </p:cTn>
-                        </p:par>
-                        <p:par>
-                          <p:cTn id="59" fill="hold">
-                            <p:stCondLst>
-                              <p:cond delay="280"/>
-                            </p:stCondLst>
-                            <p:childTnLst>
-                              <p:par>
-                                <p:cTn id="60" presetID="10" presetClass="entr" presetSubtype="0" fill="hold" grpId="0" nodeType="afterEffect">
-                                  <p:stCondLst>
-                                    <p:cond delay="0"/>
-                                  </p:stCondLst>
-                                  <p:childTnLst>
-                                    <p:set>
-                                      <p:cBhvr>
-                                        <p:cTn id="61" dur="1" fill="hold">
-                                          <p:stCondLst>
-                                            <p:cond delay="0"/>
-                                          </p:stCondLst>
-                                        </p:cTn>
-                                        <p:tgtEl>
-                                          <p:spTgt spid="16">
-                                            <p:txEl>
-                                              <p:pRg st="0" end="0"/>
-                                            </p:txEl>
-                                          </p:spTgt>
-                                        </p:tgtEl>
-                                        <p:attrNameLst>
-                                          <p:attrName>style.visibility</p:attrName>
-                                        </p:attrNameLst>
-                                      </p:cBhvr>
-                                      <p:to>
-                                        <p:strVal val="visible"/>
-                                      </p:to>
-                                    </p:set>
-                                    <p:animEffect transition="in" filter="fade">
-                                      <p:cBhvr>
-                                        <p:cTn id="62" dur="500"/>
-                                        <p:tgtEl>
-                                          <p:spTgt spid="16">
-                                            <p:txEl>
-                                              <p:pRg st="0" end="0"/>
-                                            </p:txEl>
-                                          </p:spTgt>
-                                        </p:tgtEl>
-                                      </p:cBhvr>
-                                    </p:animEffect>
-                                  </p:childTnLst>
-                                </p:cTn>
-                              </p:par>
-                            </p:childTnLst>
-                          </p:cTn>
-                        </p:par>
-                        <p:par>
-                          <p:cTn id="63" fill="hold">
-                            <p:stCondLst>
-                              <p:cond delay="560"/>
-                            </p:stCondLst>
-                            <p:childTnLst>
-                              <p:par>
-                                <p:cTn id="64" presetID="10" presetClass="entr" presetSubtype="0" fill="hold" grpId="0" nodeType="afterEffect">
-                                  <p:stCondLst>
-                                    <p:cond delay="0"/>
-                                  </p:stCondLst>
-                                  <p:childTnLst>
-                                    <p:set>
-                                      <p:cBhvr>
-                                        <p:cTn id="65" dur="1" fill="hold">
-                                          <p:stCondLst>
-                                            <p:cond delay="0"/>
-                                          </p:stCondLst>
-                                        </p:cTn>
-                                        <p:tgtEl>
-                                          <p:spTgt spid="16">
-                                            <p:txEl>
-                                              <p:pRg st="1" end="1"/>
-                                            </p:txEl>
-                                          </p:spTgt>
-                                        </p:tgtEl>
-                                        <p:attrNameLst>
-                                          <p:attrName>style.visibility</p:attrName>
-                                        </p:attrNameLst>
-                                      </p:cBhvr>
-                                      <p:to>
-                                        <p:strVal val="visible"/>
-                                      </p:to>
-                                    </p:set>
-                                    <p:animEffect transition="in" filter="fade">
-                                      <p:cBhvr>
-                                        <p:cTn id="66" dur="500"/>
-                                        <p:tgtEl>
-                                          <p:spTgt spid="16">
-                                            <p:txEl>
-                                              <p:pRg st="1" end="1"/>
-                                            </p:txEl>
-                                          </p:spTgt>
-                                        </p:tgtEl>
-                                      </p:cBhvr>
-                                    </p:animEffect>
-                                  </p:childTnLst>
-                                </p:cTn>
-                              </p:par>
-                            </p:childTnLst>
-                          </p:cTn>
-                        </p:par>
-                        <p:par>
-                          <p:cTn id="67" fill="hold">
-                            <p:stCondLst>
-                              <p:cond delay="840"/>
-                            </p:stCondLst>
-                            <p:childTnLst>
-                              <p:par>
-                                <p:cTn id="68" presetID="10" presetClass="entr" presetSubtype="0" fill="hold" grpId="0" nodeType="afterEffect">
-                                  <p:stCondLst>
-                                    <p:cond delay="0"/>
-                                  </p:stCondLst>
-                                  <p:childTnLst>
-                                    <p:set>
-                                      <p:cBhvr>
-                                        <p:cTn id="69" dur="1" fill="hold">
-                                          <p:stCondLst>
-                                            <p:cond delay="0"/>
-                                          </p:stCondLst>
-                                        </p:cTn>
-                                        <p:tgtEl>
-                                          <p:spTgt spid="16">
-                                            <p:txEl>
-                                              <p:pRg st="2" end="2"/>
-                                            </p:txEl>
-                                          </p:spTgt>
-                                        </p:tgtEl>
-                                        <p:attrNameLst>
-                                          <p:attrName>style.visibility</p:attrName>
-                                        </p:attrNameLst>
-                                      </p:cBhvr>
-                                      <p:to>
-                                        <p:strVal val="visible"/>
-                                      </p:to>
-                                    </p:set>
-                                    <p:animEffect transition="in" filter="fade">
-                                      <p:cBhvr>
-                                        <p:cTn id="70" dur="500"/>
-                                        <p:tgtEl>
-                                          <p:spTgt spid="16">
-                                            <p:txEl>
-                                              <p:pRg st="2" end="2"/>
-                                            </p:txEl>
-                                          </p:spTgt>
-                                        </p:tgtEl>
-                                      </p:cBhvr>
-                                    </p:animEffect>
-                                  </p:childTnLst>
-                                </p:cTn>
-                              </p:par>
-                            </p:childTnLst>
-                          </p:cTn>
-                        </p:par>
-                        <p:par>
-                          <p:cTn id="71" fill="hold">
-                            <p:stCondLst>
-                              <p:cond delay="1120"/>
-                            </p:stCondLst>
-                            <p:childTnLst>
-                              <p:par>
-                                <p:cTn id="72" presetID="10" presetClass="entr" presetSubtype="0" fill="hold" grpId="0" nodeType="afterEffect">
-                                  <p:stCondLst>
-                                    <p:cond delay="0"/>
-                                  </p:stCondLst>
-                                  <p:childTnLst>
-                                    <p:set>
-                                      <p:cBhvr>
-                                        <p:cTn id="73" dur="1" fill="hold">
-                                          <p:stCondLst>
-                                            <p:cond delay="0"/>
-                                          </p:stCondLst>
-                                        </p:cTn>
-                                        <p:tgtEl>
-                                          <p:spTgt spid="16">
-                                            <p:txEl>
-                                              <p:pRg st="3" end="3"/>
-                                            </p:txEl>
-                                          </p:spTgt>
-                                        </p:tgtEl>
-                                        <p:attrNameLst>
-                                          <p:attrName>style.visibility</p:attrName>
-                                        </p:attrNameLst>
-                                      </p:cBhvr>
-                                      <p:to>
-                                        <p:strVal val="visible"/>
-                                      </p:to>
-                                    </p:set>
-                                    <p:animEffect transition="in" filter="fade">
-                                      <p:cBhvr>
-                                        <p:cTn id="74" dur="500"/>
-                                        <p:tgtEl>
-                                          <p:spTgt spid="16">
-                                            <p:txEl>
-                                              <p:pRg st="3" end="3"/>
-                                            </p:txEl>
-                                          </p:spTgt>
-                                        </p:tgtEl>
-                                      </p:cBhvr>
-                                    </p:animEffect>
-                                  </p:childTnLst>
-                                </p:cTn>
-                              </p:par>
-                            </p:childTnLst>
-                          </p:cTn>
-                        </p:par>
-                      </p:childTnLst>
-                    </p:cTn>
-                  </p:par>
-                  <p:par>
-                    <p:cTn id="75" fill="hold">
-                      <p:stCondLst>
-                        <p:cond delay="indefinite"/>
-                      </p:stCondLst>
-                      <p:childTnLst>
-                        <p:par>
-                          <p:cTn id="76" fill="hold">
-                            <p:stCondLst>
-                              <p:cond delay="0"/>
-                            </p:stCondLst>
-                            <p:childTnLst>
-                              <p:par>
-                                <p:cTn id="77" presetID="22" presetClass="entr" presetSubtype="8" fill="hold" nodeType="clickEffect">
-                                  <p:stCondLst>
-                                    <p:cond delay="0"/>
-                                  </p:stCondLst>
-                                  <p:childTnLst>
-                                    <p:set>
-                                      <p:cBhvr>
-                                        <p:cTn id="78" dur="1" fill="hold">
-                                          <p:stCondLst>
-                                            <p:cond delay="0"/>
-                                          </p:stCondLst>
-                                        </p:cTn>
-                                        <p:tgtEl>
-                                          <p:spTgt spid="17"/>
-                                        </p:tgtEl>
-                                        <p:attrNameLst>
-                                          <p:attrName>style.visibility</p:attrName>
-                                        </p:attrNameLst>
-                                      </p:cBhvr>
-                                      <p:to>
-                                        <p:strVal val="visible"/>
-                                      </p:to>
-                                    </p:set>
-                                    <p:animEffect transition="in" filter="wipe(left)">
-                                      <p:cBhvr>
-                                        <p:cTn id="79" dur="600"/>
-                                        <p:tgtEl>
-                                          <p:spTgt spid="17"/>
-                                        </p:tgtEl>
-                                      </p:cBhvr>
-                                    </p:animEffect>
-                                  </p:childTnLst>
-                                </p:cTn>
-                              </p:par>
-                              <p:par>
-                                <p:cTn id="80" presetID="10" presetClass="entr" presetSubtype="0" fill="hold" grpId="0" nodeType="withEffect">
-                                  <p:stCondLst>
-                                    <p:cond delay="0"/>
-                                  </p:stCondLst>
-                                  <p:childTnLst>
-                                    <p:set>
-                                      <p:cBhvr>
-                                        <p:cTn id="81" dur="1" fill="hold">
-                                          <p:stCondLst>
-                                            <p:cond delay="0"/>
-                                          </p:stCondLst>
-                                        </p:cTn>
-                                        <p:tgtEl>
-                                          <p:spTgt spid="18"/>
-                                        </p:tgtEl>
-                                        <p:attrNameLst>
-                                          <p:attrName>style.visibility</p:attrName>
-                                        </p:attrNameLst>
-                                      </p:cBhvr>
-                                      <p:to>
-                                        <p:strVal val="visible"/>
-                                      </p:to>
-                                    </p:set>
-                                    <p:animEffect transition="in" filter="fade">
-                                      <p:cBhvr>
-                                        <p:cTn id="82" dur="500"/>
-                                        <p:tgtEl>
-                                          <p:spTgt spid="18"/>
-                                        </p:tgtEl>
-                                      </p:cBhvr>
-                                    </p:animEffect>
-                                  </p:childTnLst>
-                                </p:cTn>
-                              </p:par>
-                            </p:childTnLst>
-                          </p:cTn>
-                        </p:par>
-                      </p:childTnLst>
-                    </p:cTn>
-                  </p:par>
-                </p:childTnLst>
-              </p:cTn>
-              <p:prevCondLst>
-                <p:cond evt="onPrev" delay="0">
-                  <p:tgtEl>
-                    <p:sldTgt/>
-                  </p:tgtEl>
-                </p:cond>
-              </p:prevCondLst>
-              <p:nextCondLst>
-                <p:cond evt="onNext" delay="0">
-                  <p:tgtEl>
-                    <p:sldTgt/>
-                  </p:tgtEl>
-                </p:cond>
-              </p:nextCondLst>
-            </p:seq>
-          </p:childTnLst>
-        </p:cTn>
-      </p:par>
-    </p:tnLst>
-    <p:bldLst>
-      <p:bldP spid="3" grpId="0" animBg="1"/>
-      <p:bldP spid="4" grpId="0" animBg="1"/>
-      <p:bldP spid="5" grpId="0" animBg="1"/>
-      <p:bldP spid="6" grpId="0" animBg="1"/>
-      <p:bldP spid="7" grpId="0" animBg="1"/>
-      <p:bldP spid="8" grpId="0" animBg="1"/>
-      <p:bldP spid="10" grpId="0" animBg="1"/>
-      <p:bldP spid="11" grpId="0" build="p"/>
-      <p:bldP spid="12" grpId="0" animBg="1"/>
-      <p:bldP spid="13" grpId="0" animBg="1"/>
-      <p:bldP spid="15" grpId="0" animBg="1"/>
-      <p:bldP spid="16" grpId="0" build="p"/>
-      <p:bldP spid="18" grpId="0" animBg="1"/>
-    </p:bldLst>
-  </p:timing>
-</p:sld>
-</file>
-
-<file path=ppt/slides/slide12.xml><?xml version="1.0" encoding="utf-8"?>
-<p:sld xmlns:a="http://schemas.openxmlformats.org/drawingml/2006/main" xmlns:r="http://schemas.openxmlformats.org/officeDocument/2006/relationships" xmlns:p="http://schemas.openxmlformats.org/presentationml/2006/main">
   <p:cSld name="Slide 12">
     <p:spTree>
       <p:nvGrpSpPr>
@@ -10465,21 +8593,38 @@
           <a:bodyPr wrap="square" lIns="0" tIns="0" rIns="0" bIns="0" rtlCol="0" anchor="ctr"/>
           <a:lstStyle/>
           <a:p>
-            <a:pPr marL="0" indent="0">
-              <a:lnSpc>
-                <a:spcPct val="100000"/>
-              </a:lnSpc>
-              <a:buNone/>
-            </a:pPr>
+            <a:r>
+              <a:rPr lang="en-US" sz="1400" dirty="0" err="1">
+                <a:solidFill>
+                  <a:schemeClr val="bg1"/>
+                </a:solidFill>
+              </a:rPr>
+              <a:t>FoodScope</a:t>
+            </a:r>
             <a:r>
               <a:rPr lang="en-US" sz="1400" dirty="0">
                 <a:solidFill>
                   <a:schemeClr val="bg1"/>
                 </a:solidFill>
               </a:rPr>
-              <a:t>FoodScope takes real USDA food tables and turns them into a knowledge graph. Each step checks the one before it: the mapped graph must pass ten SHACL rules and the reasoner must find no contradiction before anything is loaded into Fuseki. On top, anyone can ask a question in English. Entity resolution and two learning models run on the side: we measure them, but never show their predictions as facts.</a:t>
+              <a:t> transforms USDA food data into a validated and reasoned Knowledge Graph through a structured pipeline. We first prepare and profile the data, then use R2RML to generate RDF triples. SHACL validates data quality, The resulting graph is stored in </a:t>
             </a:r>
-            <a:endParaRPr lang="en-US" sz="1400" dirty="0"/>
+            <a:r>
+              <a:rPr lang="en-US" sz="1400" dirty="0" err="1">
+                <a:solidFill>
+                  <a:schemeClr val="bg1"/>
+                </a:solidFill>
+              </a:rPr>
+              <a:t>Fuseki</a:t>
+            </a:r>
+            <a:r>
+              <a:rPr lang="en-US" sz="1400" dirty="0">
+                <a:solidFill>
+                  <a:schemeClr val="bg1"/>
+                </a:solidFill>
+              </a:rPr>
+              <a:t> and queried using SPARQL. Gemini enables natural-language questions through a validated text-to-SPARQL access layer. </a:t>
+            </a:r>
           </a:p>
         </p:txBody>
       </p:sp>
@@ -10503,7 +8648,7 @@
           </a:prstGeom>
           <a:extLst>
             <a:ext uri="{C572A759-6A51-4108-AA02-DFA0A04FC94B}">
-              <ma14:wrappingTextBoxFlag xmlns:ma14="http://schemas.microsoft.com/office/mac/drawingml/2011/main" xmlns="" val="0"/>
+              <ma14:wrappingTextBoxFlag xmlns="" xmlns:ma14="http://schemas.microsoft.com/office/mac/drawingml/2011/main" val="0"/>
             </a:ext>
           </a:extLst>
         </p:spPr>
@@ -12847,21 +10992,30 @@
           <a:bodyPr wrap="square" lIns="0" tIns="0" rIns="0" bIns="0" rtlCol="0" anchor="ctr"/>
           <a:lstStyle/>
           <a:p>
-            <a:pPr marL="0" indent="0">
-              <a:lnSpc>
-                <a:spcPct val="100000"/>
-              </a:lnSpc>
-              <a:buNone/>
-            </a:pPr>
             <a:r>
               <a:rPr lang="en-US" sz="1400" dirty="0">
                 <a:solidFill>
                   <a:schemeClr val="bg1"/>
                 </a:solidFill>
               </a:rPr>
-              <a:t>USDA publishes food composition as CSV files: one food is spread over many rows, nutrients are only numbers, and a missing value looks like nothing. We wrote six competency questions first, such as “how much protein does a food have?” or “which foods pass a threshold?”, and built the graph to answer them. What the data does not hold, like prices or allergens, the system refuses.</a:t>
+              <a:t>Our project uses USDA food data containing </a:t>
             </a:r>
-            <a:endParaRPr lang="en-US" sz="1400" dirty="0"/>
+            <a:r>
+              <a:rPr lang="en-US" sz="1400" b="1" dirty="0">
+                <a:solidFill>
+                  <a:schemeClr val="bg1"/>
+                </a:solidFill>
+              </a:rPr>
+              <a:t>358 foods and 1,499 nutrient measurements</a:t>
+            </a:r>
+            <a:r>
+              <a:rPr lang="en-US" sz="1400" dirty="0">
+                <a:solidFill>
+                  <a:schemeClr val="bg1"/>
+                </a:solidFill>
+              </a:rPr>
+              <a:t>. We built a knowledge graph to answer questions about nutritional values, identify foods that meet specific conditions, and detect missing information. The graph also recognizes its limitations and avoids answering questions about unavailable data, such as food prices.</a:t>
+            </a:r>
           </a:p>
         </p:txBody>
       </p:sp>
@@ -12885,7 +11039,7 @@
           </a:prstGeom>
           <a:extLst>
             <a:ext uri="{C572A759-6A51-4108-AA02-DFA0A04FC94B}">
-              <ma14:wrappingTextBoxFlag xmlns:ma14="http://schemas.microsoft.com/office/mac/drawingml/2011/main" xmlns="" val="0"/>
+              <ma14:wrappingTextBoxFlag xmlns="" xmlns:ma14="http://schemas.microsoft.com/office/mac/drawingml/2011/main" val="0"/>
             </a:ext>
           </a:extLst>
         </p:spPr>
@@ -14229,27 +12383,21 @@
           <a:bodyPr wrap="square" lIns="0" tIns="0" rIns="0" bIns="0" rtlCol="0" anchor="ctr"/>
           <a:lstStyle/>
           <a:p>
-            <a:pPr marL="0" indent="0">
-              <a:lnSpc>
-                <a:spcPct val="100000"/>
-              </a:lnSpc>
-              <a:buNone/>
-            </a:pPr>
             <a:r>
               <a:rPr lang="en-US" sz="1400" dirty="0">
                 <a:solidFill>
                   <a:schemeClr val="bg1"/>
                 </a:solidFill>
               </a:rPr>
-              <a:t>Before modelling, we profiled the four tables and wrote down every rule we found, with the count that proves it. Nine of our ten rules hold with zero exceptions. One rule was wrong: we expected every food to have all six nutrients, but </a:t>
+              <a:t>Before building the knowledge graph, we analyzed the USDA data and defined rules to ensure its quality. </a:t>
             </a:r>
             <a:r>
               <a:rPr lang="en-US" sz="1400" b="1" dirty="0">
                 <a:solidFill>
-                  <a:schemeClr val="accent6"/>
+                  <a:schemeClr val="bg1"/>
                 </a:solidFill>
               </a:rPr>
-              <a:t>353</a:t>
+              <a:t>Nine out of ten rules passed</a:t>
             </a:r>
             <a:r>
               <a:rPr lang="en-US" sz="1400" dirty="0">
@@ -14257,25 +12405,8 @@
                   <a:schemeClr val="bg1"/>
                 </a:solidFill>
               </a:rPr>
-              <a:t> of </a:t>
+              <a:t> without errors. However, most foods have missing nutrient measurements because USDA does not measure every nutrient for every food. We handle these missing values as unknown rather than zero, ensuring the graph provides accurate and reliable information.</a:t>
             </a:r>
-            <a:r>
-              <a:rPr lang="en-US" sz="1400" b="1" dirty="0">
-                <a:solidFill>
-                  <a:schemeClr val="accent6"/>
-                </a:solidFill>
-              </a:rPr>
-              <a:t>358</a:t>
-            </a:r>
-            <a:r>
-              <a:rPr lang="en-US" sz="1400" dirty="0">
-                <a:solidFill>
-                  <a:schemeClr val="bg1"/>
-                </a:solidFill>
-              </a:rPr>
-              <a:t> foods miss at least one, mostly sugars, because USDA measures only some nutrients per food. We keep it as a warning and never write zero for a missing value.</a:t>
-            </a:r>
-            <a:endParaRPr lang="en-US" sz="1400" dirty="0"/>
           </a:p>
         </p:txBody>
       </p:sp>
@@ -14299,7 +12430,7 @@
           </a:prstGeom>
           <a:extLst>
             <a:ext uri="{C572A759-6A51-4108-AA02-DFA0A04FC94B}">
-              <ma14:wrappingTextBoxFlag xmlns:ma14="http://schemas.microsoft.com/office/mac/drawingml/2011/main" xmlns="" val="0"/>
+              <ma14:wrappingTextBoxFlag xmlns="" xmlns:ma14="http://schemas.microsoft.com/office/mac/drawingml/2011/main" val="0"/>
             </a:ext>
           </a:extLst>
         </p:spPr>
@@ -16065,27 +14196,29 @@
           <a:bodyPr wrap="square" lIns="0" tIns="0" rIns="0" bIns="0" rtlCol="0" anchor="ctr"/>
           <a:lstStyle/>
           <a:p>
-            <a:pPr marL="0" indent="0">
-              <a:lnSpc>
-                <a:spcPct val="100000"/>
-              </a:lnSpc>
-              <a:buNone/>
-            </a:pPr>
             <a:r>
               <a:rPr lang="en-US" sz="1400" dirty="0">
                 <a:solidFill>
                   <a:schemeClr val="bg1"/>
                 </a:solidFill>
               </a:rPr>
-              <a:t>Our Food class is a subclass of FoodOn’s food product, so every food is also a food material and a material entity. We added only what FoodOn lacks: Nutrient, Observation, Category and one defined class, CharacterizedFood, a food with at least one measurement. HermiT classifies </a:t>
+              <a:t>We reused the existing </a:t>
+            </a:r>
+            <a:r>
+              <a:rPr lang="en-US" sz="1400" b="1" dirty="0" err="1">
+                <a:solidFill>
+                  <a:schemeClr val="bg1"/>
+                </a:solidFill>
+              </a:rPr>
+              <a:t>FoodOn</a:t>
             </a:r>
             <a:r>
               <a:rPr lang="en-US" sz="1400" b="1" dirty="0">
                 <a:solidFill>
-                  <a:schemeClr val="accent6"/>
+                  <a:schemeClr val="bg1"/>
                 </a:solidFill>
               </a:rPr>
-              <a:t>350</a:t>
+              <a:t> ontology</a:t>
             </a:r>
             <a:r>
               <a:rPr lang="en-US" sz="1400" dirty="0">
@@ -16093,9 +14226,48 @@
                   <a:schemeClr val="bg1"/>
                 </a:solidFill>
               </a:rPr>
-              <a:t> foods into it with no hand typing. Every class answers a competency question, and the ontology has a version IRI.</a:t>
+              <a:t> and extended it with the concepts needed for our project, including foods, nutrients, measurements, and categories. This allows us to organize food information and define relationships between concepts. Using the </a:t>
             </a:r>
-            <a:endParaRPr lang="en-US" sz="1400" dirty="0"/>
+            <a:r>
+              <a:rPr lang="en-US" sz="1400" b="1" dirty="0" err="1">
+                <a:solidFill>
+                  <a:schemeClr val="bg1"/>
+                </a:solidFill>
+              </a:rPr>
+              <a:t>HermiT</a:t>
+            </a:r>
+            <a:r>
+              <a:rPr lang="en-US" sz="1400" b="1" dirty="0">
+                <a:solidFill>
+                  <a:schemeClr val="bg1"/>
+                </a:solidFill>
+              </a:rPr>
+              <a:t> reasoner</a:t>
+            </a:r>
+            <a:r>
+              <a:rPr lang="en-US" sz="1400" dirty="0">
+                <a:solidFill>
+                  <a:schemeClr val="bg1"/>
+                </a:solidFill>
+              </a:rPr>
+              <a:t>, we automatically classified </a:t>
+            </a:r>
+            <a:r>
+              <a:rPr lang="en-US" sz="1400" b="1" dirty="0">
+                <a:solidFill>
+                  <a:schemeClr val="bg1"/>
+                </a:solidFill>
+              </a:rPr>
+              <a:t>350 foods</a:t>
+            </a:r>
+            <a:r>
+              <a:rPr lang="en-US" sz="1400" dirty="0">
+                <a:solidFill>
+                  <a:schemeClr val="bg1"/>
+                </a:solidFill>
+              </a:rPr>
+              <a:t> based on their nutritional measurements, confirming that our ontology is logically consistent.</a:t>
+            </a:r>
           </a:p>
         </p:txBody>
       </p:sp>
@@ -16119,7 +14291,7 @@
           </a:prstGeom>
           <a:extLst>
             <a:ext uri="{C572A759-6A51-4108-AA02-DFA0A04FC94B}">
-              <ma14:wrappingTextBoxFlag xmlns:ma14="http://schemas.microsoft.com/office/mac/drawingml/2011/main" xmlns="" val="0"/>
+              <ma14:wrappingTextBoxFlag xmlns="" xmlns:ma14="http://schemas.microsoft.com/office/mac/drawingml/2011/main" val="0"/>
             </a:ext>
           </a:extLst>
         </p:spPr>
@@ -18282,21 +16454,62 @@
           <a:bodyPr wrap="square" lIns="0" tIns="0" rIns="0" bIns="0" rtlCol="0" anchor="ctr"/>
           <a:lstStyle/>
           <a:p>
-            <a:pPr marL="0" indent="0">
-              <a:lnSpc>
-                <a:spcPct val="100000"/>
-              </a:lnSpc>
-              <a:buNone/>
-            </a:pPr>
             <a:r>
               <a:rPr lang="en-US" sz="1400" dirty="0">
                 <a:solidFill>
                   <a:schemeClr val="bg1"/>
                 </a:solidFill>
               </a:rPr>
-              <a:t>Our shapes cover all ten rules of the inventory, and every check has a clear message and a severity. A Violation stops the pipeline before the reasoner and before anything is loaded; a Warning is reported and the data is kept. The same gate runs in GitHub Actions on every push. We broke one row on purpose, and the gate stopped it. We use SHACL here because OWL is open world and cannot reject missing data.</a:t>
+              <a:t>We used </a:t>
             </a:r>
-            <a:endParaRPr lang="en-US" sz="1400" dirty="0"/>
+            <a:r>
+              <a:rPr lang="en-US" sz="1400" b="1" dirty="0">
+                <a:solidFill>
+                  <a:schemeClr val="bg1"/>
+                </a:solidFill>
+              </a:rPr>
+              <a:t>SHACL</a:t>
+            </a:r>
+            <a:r>
+              <a:rPr lang="en-US" sz="1400" dirty="0">
+                <a:solidFill>
+                  <a:schemeClr val="bg1"/>
+                </a:solidFill>
+              </a:rPr>
+              <a:t> to validate our knowledge graph before loading it into the system. It checks the data against </a:t>
+            </a:r>
+            <a:r>
+              <a:rPr lang="en-US" sz="1400" b="1" dirty="0">
+                <a:solidFill>
+                  <a:schemeClr val="bg1"/>
+                </a:solidFill>
+              </a:rPr>
+              <a:t>10 predefined rules</a:t>
+            </a:r>
+            <a:r>
+              <a:rPr lang="en-US" sz="1400" dirty="0">
+                <a:solidFill>
+                  <a:schemeClr val="bg1"/>
+                </a:solidFill>
+              </a:rPr>
+              <a:t> to ensure accuracy and consistency. Our graph passed with </a:t>
+            </a:r>
+            <a:r>
+              <a:rPr lang="en-US" sz="1400" b="1" dirty="0">
+                <a:solidFill>
+                  <a:schemeClr val="bg1"/>
+                </a:solidFill>
+              </a:rPr>
+              <a:t>zero violations</a:t>
+            </a:r>
+            <a:r>
+              <a:rPr lang="en-US" sz="1400" dirty="0">
+                <a:solidFill>
+                  <a:schemeClr val="bg1"/>
+                </a:solidFill>
+              </a:rPr>
+              <a:t>, while missing nutrient measurements were reported as warnings. We also tested the validation by introducing an incorrect negative value, which SHACL successfully detected and blocked. This ensures that invalid data cannot enter our system.</a:t>
+            </a:r>
           </a:p>
         </p:txBody>
       </p:sp>
@@ -18320,7 +16533,7 @@
           </a:prstGeom>
           <a:extLst>
             <a:ext uri="{C572A759-6A51-4108-AA02-DFA0A04FC94B}">
-              <ma14:wrappingTextBoxFlag xmlns:ma14="http://schemas.microsoft.com/office/mac/drawingml/2011/main" xmlns="" val="0"/>
+              <ma14:wrappingTextBoxFlag xmlns="" xmlns:ma14="http://schemas.microsoft.com/office/mac/drawingml/2011/main" val="0"/>
             </a:ext>
           </a:extLst>
         </p:spPr>
@@ -19475,47 +17688,6 @@
         <p:spPr>
           <a:xfrm>
             <a:off x="4325112" y="1600200"/>
-            <a:ext cx="3538728" cy="3246120"/>
-          </a:xfrm>
-          <a:prstGeom prst="roundRect">
-            <a:avLst>
-              <a:gd name="adj" fmla="val 3944"/>
-            </a:avLst>
-          </a:prstGeom>
-          <a:solidFill>
-            <a:schemeClr val="bg1"/>
-          </a:solidFill>
-          <a:ln w="9525">
-            <a:solidFill>
-              <a:srgbClr val="DCE8DF"/>
-            </a:solidFill>
-            <a:prstDash val="solid"/>
-          </a:ln>
-          <a:effectLst>
-            <a:outerShdw blurRad="127000" dist="25400" dir="5400000" algn="bl" rotWithShape="0">
-              <a:srgbClr val="1B2A22">
-                <a:alpha val="14000"/>
-              </a:srgbClr>
-            </a:outerShdw>
-          </a:effectLst>
-        </p:spPr>
-        <p:txBody>
-          <a:bodyPr/>
-          <a:lstStyle/>
-          <a:p>
-            <a:endParaRPr lang="en-US"/>
-          </a:p>
-        </p:txBody>
-      </p:sp>
-      <p:sp>
-        <p:nvSpPr>
-          <p:cNvPr id="7" name="a5_col2"/>
-          <p:cNvSpPr/>
-          <p:nvPr/>
-        </p:nvSpPr>
-        <p:spPr>
-          <a:xfrm>
-            <a:off x="8101584" y="1600200"/>
             <a:ext cx="3538728" cy="3246120"/>
           </a:xfrm>
           <a:prstGeom prst="roundRect">
@@ -20656,41 +18828,147 @@
       </p:sp>
       <p:sp>
         <p:nvSpPr>
-          <p:cNvPr id="19" name="a5_b2_c"/>
-          <p:cNvSpPr/>
+          <p:cNvPr id="22" name="a6_p_n"/>
+          <p:cNvSpPr txBox="1"/>
           <p:nvPr/>
         </p:nvSpPr>
         <p:spPr>
           <a:xfrm>
-            <a:off x="8330184" y="1773936"/>
-            <a:ext cx="548640" cy="548640"/>
-          </a:xfrm>
-          <a:prstGeom prst="ellipse">
+            <a:off x="8330184" y="2514600"/>
+            <a:ext cx="1463040" cy="594360"/>
+          </a:xfrm>
+          <a:prstGeom prst="rect">
             <a:avLst/>
           </a:prstGeom>
-          <a:solidFill>
-            <a:schemeClr val="accent3"/>
-          </a:solidFill>
+          <a:noFill/>
           <a:ln/>
-          <a:effectLst>
-            <a:outerShdw blurRad="101600" dist="25400" dir="5400000" algn="bl" rotWithShape="0">
-              <a:srgbClr val="1B2A22">
-                <a:alpha val="18000"/>
-              </a:srgbClr>
-            </a:outerShdw>
-          </a:effectLst>
-        </p:spPr>
-        <p:txBody>
-          <a:bodyPr/>
+        </p:spPr>
+        <p:txBody>
+          <a:bodyPr wrap="square" lIns="0" tIns="0" rIns="0" bIns="0" rtlCol="0" anchor="b"/>
           <a:lstStyle/>
           <a:p>
-            <a:endParaRPr lang="en-US"/>
+            <a:pPr marL="0" indent="0">
+              <a:buNone/>
+            </a:pPr>
+            <a:endParaRPr lang="en-US" sz="3400" dirty="0"/>
+          </a:p>
+        </p:txBody>
+      </p:sp>
+      <p:sp>
+        <p:nvSpPr>
+          <p:cNvPr id="23" name="a6_p_l"/>
+          <p:cNvSpPr txBox="1"/>
+          <p:nvPr/>
+        </p:nvSpPr>
+        <p:spPr>
+          <a:xfrm>
+            <a:off x="8330184" y="3154680"/>
+            <a:ext cx="1463040" cy="411480"/>
+          </a:xfrm>
+          <a:prstGeom prst="rect">
+            <a:avLst/>
+          </a:prstGeom>
+          <a:noFill/>
+          <a:ln/>
+        </p:spPr>
+        <p:txBody>
+          <a:bodyPr wrap="square" lIns="0" tIns="0" rIns="0" bIns="0" rtlCol="0" anchor="t"/>
+          <a:lstStyle/>
+          <a:p>
+            <a:pPr marL="0" indent="0">
+              <a:buNone/>
+            </a:pPr>
+            <a:endParaRPr lang="en-US" sz="1400" dirty="0"/>
+          </a:p>
+        </p:txBody>
+      </p:sp>
+      <p:sp>
+        <p:nvSpPr>
+          <p:cNvPr id="24" name="a6_r_n"/>
+          <p:cNvSpPr txBox="1"/>
+          <p:nvPr/>
+        </p:nvSpPr>
+        <p:spPr>
+          <a:xfrm>
+            <a:off x="9884664" y="2514600"/>
+            <a:ext cx="1463040" cy="594360"/>
+          </a:xfrm>
+          <a:prstGeom prst="rect">
+            <a:avLst/>
+          </a:prstGeom>
+          <a:noFill/>
+          <a:ln/>
+        </p:spPr>
+        <p:txBody>
+          <a:bodyPr wrap="square" lIns="0" tIns="0" rIns="0" bIns="0" rtlCol="0" anchor="b"/>
+          <a:lstStyle/>
+          <a:p>
+            <a:pPr marL="0" indent="0">
+              <a:buNone/>
+            </a:pPr>
+            <a:endParaRPr lang="en-US" sz="3400" dirty="0"/>
+          </a:p>
+        </p:txBody>
+      </p:sp>
+      <p:sp>
+        <p:nvSpPr>
+          <p:cNvPr id="25" name="a6_r_l"/>
+          <p:cNvSpPr txBox="1"/>
+          <p:nvPr/>
+        </p:nvSpPr>
+        <p:spPr>
+          <a:xfrm>
+            <a:off x="9884664" y="3154680"/>
+            <a:ext cx="1463040" cy="411480"/>
+          </a:xfrm>
+          <a:prstGeom prst="rect">
+            <a:avLst/>
+          </a:prstGeom>
+          <a:noFill/>
+          <a:ln/>
+        </p:spPr>
+        <p:txBody>
+          <a:bodyPr wrap="square" lIns="0" tIns="0" rIns="0" bIns="0" rtlCol="0" anchor="t"/>
+          <a:lstStyle/>
+          <a:p>
+            <a:pPr marL="0" indent="0">
+              <a:buNone/>
+            </a:pPr>
+            <a:endParaRPr lang="en-US" sz="1400" dirty="0"/>
+          </a:p>
+        </p:txBody>
+      </p:sp>
+      <p:sp>
+        <p:nvSpPr>
+          <p:cNvPr id="26" name="a6_rt"/>
+          <p:cNvSpPr txBox="1"/>
+          <p:nvPr/>
+        </p:nvSpPr>
+        <p:spPr>
+          <a:xfrm>
+            <a:off x="8330184" y="3703320"/>
+            <a:ext cx="3108960" cy="731520"/>
+          </a:xfrm>
+          <a:prstGeom prst="rect">
+            <a:avLst/>
+          </a:prstGeom>
+          <a:noFill/>
+          <a:ln/>
+        </p:spPr>
+        <p:txBody>
+          <a:bodyPr wrap="square" lIns="0" tIns="0" rIns="0" bIns="0" rtlCol="0" anchor="t"/>
+          <a:lstStyle/>
+          <a:p>
+            <a:pPr marL="0" indent="0">
+              <a:buNone/>
+            </a:pPr>
+            <a:endParaRPr lang="en-US" sz="1400" dirty="0"/>
           </a:p>
         </p:txBody>
       </p:sp>
       <p:pic>
         <p:nvPicPr>
-          <p:cNvPr id="20" name="a5_b2_i" descr="preencoded.png"/>
+          <p:cNvPr id="27" name="a7_desc_bg" descr="preencoded.png"/>
           <p:cNvPicPr>
             <a:picLocks noChangeAspect="1"/>
           </p:cNvPicPr>
@@ -20704,246 +18982,6 @@
         </p:blipFill>
         <p:spPr>
           <a:xfrm>
-            <a:off x="8467344" y="1911096"/>
-            <a:ext cx="274320" cy="274320"/>
-          </a:xfrm>
-          <a:prstGeom prst="rect">
-            <a:avLst/>
-          </a:prstGeom>
-        </p:spPr>
-      </p:pic>
-      <p:sp>
-        <p:nvSpPr>
-          <p:cNvPr id="21" name="a5_h2"/>
-          <p:cNvSpPr txBox="1"/>
-          <p:nvPr/>
-        </p:nvSpPr>
-        <p:spPr>
-          <a:xfrm>
-            <a:off x="8997696" y="1737360"/>
-            <a:ext cx="2560320" cy="621792"/>
-          </a:xfrm>
-          <a:prstGeom prst="rect">
-            <a:avLst/>
-          </a:prstGeom>
-          <a:noFill/>
-          <a:ln/>
-        </p:spPr>
-        <p:txBody>
-          <a:bodyPr wrap="square" lIns="0" tIns="0" rIns="0" bIns="0" rtlCol="0" anchor="ctr"/>
-          <a:lstStyle/>
-          <a:p>
-            <a:pPr marL="0" indent="0">
-              <a:buNone/>
-            </a:pPr>
-            <a:r>
-              <a:rPr lang="en-US" sz="1600" b="1" dirty="0">
-                <a:solidFill>
-                  <a:schemeClr val="tx2"/>
-                </a:solidFill>
-              </a:rPr>
-              <a:t>Entity resolution</a:t>
-            </a:r>
-            <a:endParaRPr lang="en-US" sz="1600" dirty="0"/>
-          </a:p>
-        </p:txBody>
-      </p:sp>
-      <p:sp>
-        <p:nvSpPr>
-          <p:cNvPr id="22" name="a6_p_n"/>
-          <p:cNvSpPr txBox="1"/>
-          <p:nvPr/>
-        </p:nvSpPr>
-        <p:spPr>
-          <a:xfrm>
-            <a:off x="8330184" y="2514600"/>
-            <a:ext cx="1463040" cy="594360"/>
-          </a:xfrm>
-          <a:prstGeom prst="rect">
-            <a:avLst/>
-          </a:prstGeom>
-          <a:noFill/>
-          <a:ln/>
-        </p:spPr>
-        <p:txBody>
-          <a:bodyPr wrap="square" lIns="0" tIns="0" rIns="0" bIns="0" rtlCol="0" anchor="b"/>
-          <a:lstStyle/>
-          <a:p>
-            <a:pPr marL="0" indent="0">
-              <a:buNone/>
-            </a:pPr>
-            <a:r>
-              <a:rPr lang="en-US" sz="3400" b="1" dirty="0">
-                <a:solidFill>
-                  <a:schemeClr val="accent1"/>
-                </a:solidFill>
-              </a:rPr>
-              <a:t>0.684</a:t>
-            </a:r>
-            <a:endParaRPr lang="en-US" sz="3400" dirty="0"/>
-          </a:p>
-        </p:txBody>
-      </p:sp>
-      <p:sp>
-        <p:nvSpPr>
-          <p:cNvPr id="23" name="a6_p_l"/>
-          <p:cNvSpPr txBox="1"/>
-          <p:nvPr/>
-        </p:nvSpPr>
-        <p:spPr>
-          <a:xfrm>
-            <a:off x="8330184" y="3154680"/>
-            <a:ext cx="1463040" cy="411480"/>
-          </a:xfrm>
-          <a:prstGeom prst="rect">
-            <a:avLst/>
-          </a:prstGeom>
-          <a:noFill/>
-          <a:ln/>
-        </p:spPr>
-        <p:txBody>
-          <a:bodyPr wrap="square" lIns="0" tIns="0" rIns="0" bIns="0" rtlCol="0" anchor="t"/>
-          <a:lstStyle/>
-          <a:p>
-            <a:pPr marL="0" indent="0">
-              <a:buNone/>
-            </a:pPr>
-            <a:r>
-              <a:rPr lang="en-US" sz="1400" dirty="0">
-                <a:solidFill>
-                  <a:schemeClr val="accent5"/>
-                </a:solidFill>
-              </a:rPr>
-              <a:t>precision</a:t>
-            </a:r>
-            <a:endParaRPr lang="en-US" sz="1400" dirty="0"/>
-          </a:p>
-        </p:txBody>
-      </p:sp>
-      <p:sp>
-        <p:nvSpPr>
-          <p:cNvPr id="24" name="a6_r_n"/>
-          <p:cNvSpPr txBox="1"/>
-          <p:nvPr/>
-        </p:nvSpPr>
-        <p:spPr>
-          <a:xfrm>
-            <a:off x="9884664" y="2514600"/>
-            <a:ext cx="1463040" cy="594360"/>
-          </a:xfrm>
-          <a:prstGeom prst="rect">
-            <a:avLst/>
-          </a:prstGeom>
-          <a:noFill/>
-          <a:ln/>
-        </p:spPr>
-        <p:txBody>
-          <a:bodyPr wrap="square" lIns="0" tIns="0" rIns="0" bIns="0" rtlCol="0" anchor="b"/>
-          <a:lstStyle/>
-          <a:p>
-            <a:pPr marL="0" indent="0">
-              <a:buNone/>
-            </a:pPr>
-            <a:r>
-              <a:rPr lang="en-US" sz="3400" b="1" dirty="0">
-                <a:solidFill>
-                  <a:schemeClr val="accent2"/>
-                </a:solidFill>
-              </a:rPr>
-              <a:t>0.406</a:t>
-            </a:r>
-            <a:endParaRPr lang="en-US" sz="3400" dirty="0"/>
-          </a:p>
-        </p:txBody>
-      </p:sp>
-      <p:sp>
-        <p:nvSpPr>
-          <p:cNvPr id="25" name="a6_r_l"/>
-          <p:cNvSpPr txBox="1"/>
-          <p:nvPr/>
-        </p:nvSpPr>
-        <p:spPr>
-          <a:xfrm>
-            <a:off x="9884664" y="3154680"/>
-            <a:ext cx="1463040" cy="411480"/>
-          </a:xfrm>
-          <a:prstGeom prst="rect">
-            <a:avLst/>
-          </a:prstGeom>
-          <a:noFill/>
-          <a:ln/>
-        </p:spPr>
-        <p:txBody>
-          <a:bodyPr wrap="square" lIns="0" tIns="0" rIns="0" bIns="0" rtlCol="0" anchor="t"/>
-          <a:lstStyle/>
-          <a:p>
-            <a:pPr marL="0" indent="0">
-              <a:buNone/>
-            </a:pPr>
-            <a:r>
-              <a:rPr lang="en-US" sz="1400" dirty="0">
-                <a:solidFill>
-                  <a:schemeClr val="accent5"/>
-                </a:solidFill>
-              </a:rPr>
-              <a:t>recall</a:t>
-            </a:r>
-            <a:endParaRPr lang="en-US" sz="1400" dirty="0"/>
-          </a:p>
-        </p:txBody>
-      </p:sp>
-      <p:sp>
-        <p:nvSpPr>
-          <p:cNvPr id="26" name="a6_rt"/>
-          <p:cNvSpPr txBox="1"/>
-          <p:nvPr/>
-        </p:nvSpPr>
-        <p:spPr>
-          <a:xfrm>
-            <a:off x="8330184" y="3703320"/>
-            <a:ext cx="3108960" cy="731520"/>
-          </a:xfrm>
-          <a:prstGeom prst="rect">
-            <a:avLst/>
-          </a:prstGeom>
-          <a:noFill/>
-          <a:ln/>
-        </p:spPr>
-        <p:txBody>
-          <a:bodyPr wrap="square" lIns="0" tIns="0" rIns="0" bIns="0" rtlCol="0" anchor="t"/>
-          <a:lstStyle/>
-          <a:p>
-            <a:pPr marL="0" indent="0">
-              <a:buNone/>
-            </a:pPr>
-            <a:r>
-              <a:rPr lang="en-US" sz="1400" dirty="0">
-                <a:solidFill>
-                  <a:schemeClr val="tx2"/>
-                </a:solidFill>
-              </a:rPr>
-              <a:t>40 SR Legacy (2018) records vs 358 Foundation Foods (2024)</a:t>
-            </a:r>
-            <a:endParaRPr lang="en-US" sz="1400" dirty="0"/>
-          </a:p>
-        </p:txBody>
-      </p:sp>
-      <p:pic>
-        <p:nvPicPr>
-          <p:cNvPr id="27" name="a7_desc_bg" descr="preencoded.png"/>
-          <p:cNvPicPr>
-            <a:picLocks noChangeAspect="1"/>
-          </p:cNvPicPr>
-          <p:nvPr/>
-        </p:nvPicPr>
-        <p:blipFill>
-          <a:blip r:embed="rId6"/>
-          <a:stretch>
-            <a:fillRect/>
-          </a:stretch>
-        </p:blipFill>
-        <p:spPr>
-          <a:xfrm>
             <a:off x="548640" y="5029200"/>
             <a:ext cx="11091672" cy="1261872"/>
           </a:xfrm>
@@ -20980,27 +19018,21 @@
           <a:bodyPr wrap="square" lIns="0" tIns="0" rIns="0" bIns="0" rtlCol="0" anchor="ctr"/>
           <a:lstStyle/>
           <a:p>
-            <a:pPr marL="0" indent="0">
-              <a:lnSpc>
-                <a:spcPct val="100000"/>
-              </a:lnSpc>
-              <a:buNone/>
-            </a:pPr>
             <a:r>
               <a:rPr lang="en-US" sz="1400" dirty="0">
                 <a:solidFill>
                   <a:schemeClr val="bg1"/>
                 </a:solidFill>
               </a:rPr>
-              <a:t>One R2RML mapping turns the four tables into </a:t>
+              <a:t>We use </a:t>
             </a:r>
             <a:r>
               <a:rPr lang="en-US" sz="1400" b="1" dirty="0">
                 <a:solidFill>
-                  <a:schemeClr val="accent6"/>
+                  <a:schemeClr val="bg1"/>
                 </a:solidFill>
               </a:rPr>
-              <a:t>9,359</a:t>
+              <a:t>R2RML mapping</a:t>
             </a:r>
             <a:r>
               <a:rPr lang="en-US" sz="1400" dirty="0">
@@ -21008,15 +19040,15 @@
                   <a:schemeClr val="bg1"/>
                 </a:solidFill>
               </a:rPr>
-              <a:t> triples, with IRIs built from kind, source and key. We served the same data virtually with Ontop: both count </a:t>
+              <a:t> to convert four tables into </a:t>
             </a:r>
             <a:r>
               <a:rPr lang="en-US" sz="1400" b="1" dirty="0">
                 <a:solidFill>
-                  <a:schemeClr val="accent6"/>
+                  <a:schemeClr val="bg1"/>
                 </a:solidFill>
               </a:rPr>
-              <a:t>358</a:t>
+              <a:t>9,359 RDF triples describing 358 foods</a:t>
             </a:r>
             <a:r>
               <a:rPr lang="en-US" sz="1400" dirty="0">
@@ -21024,15 +19056,15 @@
                   <a:schemeClr val="bg1"/>
                 </a:solidFill>
               </a:rPr>
-              <a:t> foods, but we materialize, because USDA releases data only about twice a year, it is faster, and Ontop cannot use our CharacterizedFood definition. Entity resolution against the </a:t>
+              <a:t>. There are two approaches: </a:t>
             </a:r>
             <a:r>
               <a:rPr lang="en-US" sz="1400" b="1" dirty="0">
                 <a:solidFill>
-                  <a:schemeClr val="accent6"/>
+                  <a:schemeClr val="bg1"/>
                 </a:solidFill>
               </a:rPr>
-              <a:t>2018</a:t>
+              <a:t>materialized</a:t>
             </a:r>
             <a:r>
               <a:rPr lang="en-US" sz="1400" dirty="0">
@@ -21040,15 +19072,15 @@
                   <a:schemeClr val="bg1"/>
                 </a:solidFill>
               </a:rPr>
-              <a:t> release reaches precision </a:t>
+              <a:t>, which generates and stores the graph before querying, and </a:t>
             </a:r>
             <a:r>
               <a:rPr lang="en-US" sz="1400" b="1" dirty="0">
                 <a:solidFill>
-                  <a:schemeClr val="accent6"/>
+                  <a:schemeClr val="bg1"/>
                 </a:solidFill>
               </a:rPr>
-              <a:t>0.684</a:t>
+              <a:t>virtual</a:t>
             </a:r>
             <a:r>
               <a:rPr lang="en-US" sz="1400" dirty="0">
@@ -21056,15 +19088,15 @@
                   <a:schemeClr val="bg1"/>
                 </a:solidFill>
               </a:rPr>
-              <a:t> and recall </a:t>
+              <a:t>, where </a:t>
             </a:r>
             <a:r>
-              <a:rPr lang="en-US" sz="1400" b="1" dirty="0">
+              <a:rPr lang="en-US" sz="1400" dirty="0" err="1">
                 <a:solidFill>
-                  <a:schemeClr val="accent6"/>
+                  <a:schemeClr val="bg1"/>
                 </a:solidFill>
               </a:rPr>
-              <a:t>0.406</a:t>
+              <a:t>Ontop</a:t>
             </a:r>
             <a:r>
               <a:rPr lang="en-US" sz="1400" dirty="0">
@@ -21072,9 +19104,24 @@
                   <a:schemeClr val="bg1"/>
                 </a:solidFill>
               </a:rPr>
-              <a:t>, so we do not merge foods.</a:t>
+              <a:t> translates SPARQL into SQL to query the database directly. </a:t>
             </a:r>
-            <a:endParaRPr lang="en-US" sz="1400" dirty="0"/>
+            <a:r>
+              <a:rPr lang="en-US" sz="1400" b="1" dirty="0">
+                <a:solidFill>
+                  <a:schemeClr val="bg1"/>
+                </a:solidFill>
+              </a:rPr>
+              <a:t>We follow the materialized approach</a:t>
+            </a:r>
+            <a:r>
+              <a:rPr lang="en-US" sz="1400" dirty="0">
+                <a:solidFill>
+                  <a:schemeClr val="bg1"/>
+                </a:solidFill>
+              </a:rPr>
+              <a:t> because it supports our required queries and performed faster .</a:t>
+            </a:r>
           </a:p>
         </p:txBody>
       </p:sp>
@@ -21098,7 +19145,7 @@
           </a:prstGeom>
           <a:extLst>
             <a:ext uri="{C572A759-6A51-4108-AA02-DFA0A04FC94B}">
-              <ma14:wrappingTextBoxFlag xmlns:ma14="http://schemas.microsoft.com/office/mac/drawingml/2011/main" xmlns="" val="0"/>
+              <ma14:wrappingTextBoxFlag xmlns="" xmlns:ma14="http://schemas.microsoft.com/office/mac/drawingml/2011/main" val="0"/>
             </a:ext>
           </a:extLst>
         </p:spPr>
@@ -21669,7 +19716,7 @@
                         <p:par>
                           <p:cTn id="49" fill="hold">
                             <p:stCondLst>
-                              <p:cond delay="280"/>
+                              <p:cond delay="600"/>
                             </p:stCondLst>
                             <p:childTnLst>
                               <p:par>
@@ -21736,6 +19783,190 @@
                                         <p:cTn id="55" dur="500"/>
                                         <p:tgtEl>
                                           <p:spTgt spid="18"/>
+                                        </p:tgtEl>
+                                      </p:cBhvr>
+                                    </p:animEffect>
+                                  </p:childTnLst>
+                                </p:cTn>
+                              </p:par>
+                            </p:childTnLst>
+                          </p:cTn>
+                        </p:par>
+                        <p:par>
+                          <p:cTn id="56" fill="hold">
+                            <p:stCondLst>
+                              <p:cond delay="1200"/>
+                            </p:stCondLst>
+                            <p:childTnLst>
+                              <p:par>
+                                <p:cTn id="57" presetID="10" presetClass="entr" presetSubtype="0" fill="hold" grpId="0" nodeType="afterEffect">
+                                  <p:stCondLst>
+                                    <p:cond delay="0"/>
+                                  </p:stCondLst>
+                                  <p:childTnLst>
+                                    <p:set>
+                                      <p:cBhvr>
+                                        <p:cTn id="58" dur="1" fill="hold">
+                                          <p:stCondLst>
+                                            <p:cond delay="0"/>
+                                          </p:stCondLst>
+                                        </p:cTn>
+                                        <p:tgtEl>
+                                          <p:spTgt spid="22"/>
+                                        </p:tgtEl>
+                                        <p:attrNameLst>
+                                          <p:attrName>style.visibility</p:attrName>
+                                        </p:attrNameLst>
+                                      </p:cBhvr>
+                                      <p:to>
+                                        <p:strVal val="visible"/>
+                                      </p:to>
+                                    </p:set>
+                                    <p:animEffect transition="in" filter="fade">
+                                      <p:cBhvr>
+                                        <p:cTn id="59" dur="500"/>
+                                        <p:tgtEl>
+                                          <p:spTgt spid="22"/>
+                                        </p:tgtEl>
+                                      </p:cBhvr>
+                                    </p:animEffect>
+                                  </p:childTnLst>
+                                </p:cTn>
+                              </p:par>
+                              <p:par>
+                                <p:cTn id="60" presetID="10" presetClass="entr" presetSubtype="0" fill="hold" grpId="0" nodeType="withEffect">
+                                  <p:stCondLst>
+                                    <p:cond delay="0"/>
+                                  </p:stCondLst>
+                                  <p:childTnLst>
+                                    <p:set>
+                                      <p:cBhvr>
+                                        <p:cTn id="61" dur="1" fill="hold">
+                                          <p:stCondLst>
+                                            <p:cond delay="0"/>
+                                          </p:stCondLst>
+                                        </p:cTn>
+                                        <p:tgtEl>
+                                          <p:spTgt spid="23"/>
+                                        </p:tgtEl>
+                                        <p:attrNameLst>
+                                          <p:attrName>style.visibility</p:attrName>
+                                        </p:attrNameLst>
+                                      </p:cBhvr>
+                                      <p:to>
+                                        <p:strVal val="visible"/>
+                                      </p:to>
+                                    </p:set>
+                                    <p:animEffect transition="in" filter="fade">
+                                      <p:cBhvr>
+                                        <p:cTn id="62" dur="500"/>
+                                        <p:tgtEl>
+                                          <p:spTgt spid="23"/>
+                                        </p:tgtEl>
+                                      </p:cBhvr>
+                                    </p:animEffect>
+                                  </p:childTnLst>
+                                </p:cTn>
+                              </p:par>
+                              <p:par>
+                                <p:cTn id="63" presetID="10" presetClass="entr" presetSubtype="0" fill="hold" grpId="0" nodeType="withEffect">
+                                  <p:stCondLst>
+                                    <p:cond delay="0"/>
+                                  </p:stCondLst>
+                                  <p:childTnLst>
+                                    <p:set>
+                                      <p:cBhvr>
+                                        <p:cTn id="64" dur="1" fill="hold">
+                                          <p:stCondLst>
+                                            <p:cond delay="0"/>
+                                          </p:stCondLst>
+                                        </p:cTn>
+                                        <p:tgtEl>
+                                          <p:spTgt spid="24"/>
+                                        </p:tgtEl>
+                                        <p:attrNameLst>
+                                          <p:attrName>style.visibility</p:attrName>
+                                        </p:attrNameLst>
+                                      </p:cBhvr>
+                                      <p:to>
+                                        <p:strVal val="visible"/>
+                                      </p:to>
+                                    </p:set>
+                                    <p:animEffect transition="in" filter="fade">
+                                      <p:cBhvr>
+                                        <p:cTn id="65" dur="500"/>
+                                        <p:tgtEl>
+                                          <p:spTgt spid="24"/>
+                                        </p:tgtEl>
+                                      </p:cBhvr>
+                                    </p:animEffect>
+                                  </p:childTnLst>
+                                </p:cTn>
+                              </p:par>
+                              <p:par>
+                                <p:cTn id="66" presetID="10" presetClass="entr" presetSubtype="0" fill="hold" grpId="0" nodeType="withEffect">
+                                  <p:stCondLst>
+                                    <p:cond delay="0"/>
+                                  </p:stCondLst>
+                                  <p:childTnLst>
+                                    <p:set>
+                                      <p:cBhvr>
+                                        <p:cTn id="67" dur="1" fill="hold">
+                                          <p:stCondLst>
+                                            <p:cond delay="0"/>
+                                          </p:stCondLst>
+                                        </p:cTn>
+                                        <p:tgtEl>
+                                          <p:spTgt spid="25"/>
+                                        </p:tgtEl>
+                                        <p:attrNameLst>
+                                          <p:attrName>style.visibility</p:attrName>
+                                        </p:attrNameLst>
+                                      </p:cBhvr>
+                                      <p:to>
+                                        <p:strVal val="visible"/>
+                                      </p:to>
+                                    </p:set>
+                                    <p:animEffect transition="in" filter="fade">
+                                      <p:cBhvr>
+                                        <p:cTn id="68" dur="500"/>
+                                        <p:tgtEl>
+                                          <p:spTgt spid="25"/>
+                                        </p:tgtEl>
+                                      </p:cBhvr>
+                                    </p:animEffect>
+                                  </p:childTnLst>
+                                </p:cTn>
+                              </p:par>
+                              <p:par>
+                                <p:cTn id="69" presetID="10" presetClass="entr" presetSubtype="0" fill="hold" grpId="0" nodeType="withEffect">
+                                  <p:stCondLst>
+                                    <p:cond delay="0"/>
+                                  </p:stCondLst>
+                                  <p:childTnLst>
+                                    <p:set>
+                                      <p:cBhvr>
+                                        <p:cTn id="70" dur="1" fill="hold">
+                                          <p:stCondLst>
+                                            <p:cond delay="0"/>
+                                          </p:stCondLst>
+                                        </p:cTn>
+                                        <p:tgtEl>
+                                          <p:spTgt spid="26"/>
+                                        </p:tgtEl>
+                                        <p:attrNameLst>
+                                          <p:attrName>style.visibility</p:attrName>
+                                        </p:attrNameLst>
+                                      </p:cBhvr>
+                                      <p:to>
+                                        <p:strVal val="visible"/>
+                                      </p:to>
+                                    </p:set>
+                                    <p:animEffect transition="in" filter="fade">
+                                      <p:cBhvr>
+                                        <p:cTn id="71" dur="500"/>
+                                        <p:tgtEl>
+                                          <p:spTgt spid="26"/>
                                         </p:tgtEl>
                                       </p:cBhvr>
                                     </p:animEffect>
@@ -21749,32 +19980,32 @@
                     </p:cTn>
                   </p:par>
                   <p:par>
-                    <p:cTn id="56" fill="hold">
+                    <p:cTn id="72" fill="hold">
                       <p:stCondLst>
                         <p:cond delay="indefinite"/>
                       </p:stCondLst>
                       <p:childTnLst>
                         <p:par>
-                          <p:cTn id="57" fill="hold">
+                          <p:cTn id="73" fill="hold">
                             <p:stCondLst>
                               <p:cond delay="0"/>
                             </p:stCondLst>
                             <p:childTnLst>
                               <p:par>
-                                <p:cTn id="58" presetID="22" presetClass="entr" presetSubtype="8" fill="hold" grpId="0" nodeType="clickEffect">
-                                  <p:stCondLst>
-                                    <p:cond delay="0"/>
-                                  </p:stCondLst>
-                                  <p:childTnLst>
-                                    <p:set>
-                                      <p:cBhvr>
-                                        <p:cTn id="59" dur="1" fill="hold">
-                                          <p:stCondLst>
-                                            <p:cond delay="0"/>
-                                          </p:stCondLst>
-                                        </p:cTn>
-                                        <p:tgtEl>
-                                          <p:spTgt spid="7"/>
+                                <p:cTn id="74" presetID="22" presetClass="entr" presetSubtype="8" fill="hold" nodeType="clickEffect">
+                                  <p:stCondLst>
+                                    <p:cond delay="0"/>
+                                  </p:stCondLst>
+                                  <p:childTnLst>
+                                    <p:set>
+                                      <p:cBhvr>
+                                        <p:cTn id="75" dur="1" fill="hold">
+                                          <p:stCondLst>
+                                            <p:cond delay="0"/>
+                                          </p:stCondLst>
+                                        </p:cTn>
+                                        <p:tgtEl>
+                                          <p:spTgt spid="27"/>
                                         </p:tgtEl>
                                         <p:attrNameLst>
                                           <p:attrName>style.visibility</p:attrName>
@@ -21786,30 +20017,30 @@
                                     </p:set>
                                     <p:animEffect transition="in" filter="wipe(left)">
                                       <p:cBhvr>
-                                        <p:cTn id="60" dur="600"/>
-                                        <p:tgtEl>
-                                          <p:spTgt spid="7"/>
-                                        </p:tgtEl>
-                                      </p:cBhvr>
-                                    </p:animEffect>
-                                  </p:childTnLst>
-                                </p:cTn>
-                              </p:par>
-                              <p:par>
-                                <p:cTn id="61" presetID="10" presetClass="entr" presetSubtype="0" fill="hold" grpId="0" nodeType="withEffect">
-                                  <p:stCondLst>
-                                    <p:cond delay="0"/>
-                                  </p:stCondLst>
-                                  <p:childTnLst>
-                                    <p:set>
-                                      <p:cBhvr>
-                                        <p:cTn id="62" dur="1" fill="hold">
-                                          <p:stCondLst>
-                                            <p:cond delay="0"/>
-                                          </p:stCondLst>
-                                        </p:cTn>
-                                        <p:tgtEl>
-                                          <p:spTgt spid="19"/>
+                                        <p:cTn id="76" dur="600"/>
+                                        <p:tgtEl>
+                                          <p:spTgt spid="27"/>
+                                        </p:tgtEl>
+                                      </p:cBhvr>
+                                    </p:animEffect>
+                                  </p:childTnLst>
+                                </p:cTn>
+                              </p:par>
+                              <p:par>
+                                <p:cTn id="77" presetID="10" presetClass="entr" presetSubtype="0" fill="hold" grpId="0" nodeType="withEffect">
+                                  <p:stCondLst>
+                                    <p:cond delay="0"/>
+                                  </p:stCondLst>
+                                  <p:childTnLst>
+                                    <p:set>
+                                      <p:cBhvr>
+                                        <p:cTn id="78" dur="1" fill="hold">
+                                          <p:stCondLst>
+                                            <p:cond delay="0"/>
+                                          </p:stCondLst>
+                                        </p:cTn>
+                                        <p:tgtEl>
+                                          <p:spTgt spid="28"/>
                                         </p:tgtEl>
                                         <p:attrNameLst>
                                           <p:attrName>style.visibility</p:attrName>
@@ -21821,349 +20052,7 @@
                                     </p:set>
                                     <p:animEffect transition="in" filter="fade">
                                       <p:cBhvr>
-                                        <p:cTn id="63" dur="500"/>
-                                        <p:tgtEl>
-                                          <p:spTgt spid="19"/>
-                                        </p:tgtEl>
-                                      </p:cBhvr>
-                                    </p:animEffect>
-                                  </p:childTnLst>
-                                </p:cTn>
-                              </p:par>
-                              <p:par>
-                                <p:cTn id="64" presetID="10" presetClass="entr" presetSubtype="0" fill="hold" nodeType="withEffect">
-                                  <p:stCondLst>
-                                    <p:cond delay="0"/>
-                                  </p:stCondLst>
-                                  <p:childTnLst>
-                                    <p:set>
-                                      <p:cBhvr>
-                                        <p:cTn id="65" dur="1" fill="hold">
-                                          <p:stCondLst>
-                                            <p:cond delay="0"/>
-                                          </p:stCondLst>
-                                        </p:cTn>
-                                        <p:tgtEl>
-                                          <p:spTgt spid="20"/>
-                                        </p:tgtEl>
-                                        <p:attrNameLst>
-                                          <p:attrName>style.visibility</p:attrName>
-                                        </p:attrNameLst>
-                                      </p:cBhvr>
-                                      <p:to>
-                                        <p:strVal val="visible"/>
-                                      </p:to>
-                                    </p:set>
-                                    <p:animEffect transition="in" filter="fade">
-                                      <p:cBhvr>
-                                        <p:cTn id="66" dur="500"/>
-                                        <p:tgtEl>
-                                          <p:spTgt spid="20"/>
-                                        </p:tgtEl>
-                                      </p:cBhvr>
-                                    </p:animEffect>
-                                  </p:childTnLst>
-                                </p:cTn>
-                              </p:par>
-                              <p:par>
-                                <p:cTn id="67" presetID="10" presetClass="entr" presetSubtype="0" fill="hold" grpId="0" nodeType="withEffect">
-                                  <p:stCondLst>
-                                    <p:cond delay="0"/>
-                                  </p:stCondLst>
-                                  <p:childTnLst>
-                                    <p:set>
-                                      <p:cBhvr>
-                                        <p:cTn id="68" dur="1" fill="hold">
-                                          <p:stCondLst>
-                                            <p:cond delay="0"/>
-                                          </p:stCondLst>
-                                        </p:cTn>
-                                        <p:tgtEl>
-                                          <p:spTgt spid="21"/>
-                                        </p:tgtEl>
-                                        <p:attrNameLst>
-                                          <p:attrName>style.visibility</p:attrName>
-                                        </p:attrNameLst>
-                                      </p:cBhvr>
-                                      <p:to>
-                                        <p:strVal val="visible"/>
-                                      </p:to>
-                                    </p:set>
-                                    <p:animEffect transition="in" filter="fade">
-                                      <p:cBhvr>
-                                        <p:cTn id="69" dur="500"/>
-                                        <p:tgtEl>
-                                          <p:spTgt spid="21"/>
-                                        </p:tgtEl>
-                                      </p:cBhvr>
-                                    </p:animEffect>
-                                  </p:childTnLst>
-                                </p:cTn>
-                              </p:par>
-                            </p:childTnLst>
-                          </p:cTn>
-                        </p:par>
-                        <p:par>
-                          <p:cTn id="70" fill="hold">
-                            <p:stCondLst>
-                              <p:cond delay="280"/>
-                            </p:stCondLst>
-                            <p:childTnLst>
-                              <p:par>
-                                <p:cTn id="71" presetID="10" presetClass="entr" presetSubtype="0" fill="hold" grpId="0" nodeType="afterEffect">
-                                  <p:stCondLst>
-                                    <p:cond delay="0"/>
-                                  </p:stCondLst>
-                                  <p:childTnLst>
-                                    <p:set>
-                                      <p:cBhvr>
-                                        <p:cTn id="72" dur="1" fill="hold">
-                                          <p:stCondLst>
-                                            <p:cond delay="0"/>
-                                          </p:stCondLst>
-                                        </p:cTn>
-                                        <p:tgtEl>
-                                          <p:spTgt spid="22"/>
-                                        </p:tgtEl>
-                                        <p:attrNameLst>
-                                          <p:attrName>style.visibility</p:attrName>
-                                        </p:attrNameLst>
-                                      </p:cBhvr>
-                                      <p:to>
-                                        <p:strVal val="visible"/>
-                                      </p:to>
-                                    </p:set>
-                                    <p:animEffect transition="in" filter="fade">
-                                      <p:cBhvr>
-                                        <p:cTn id="73" dur="500"/>
-                                        <p:tgtEl>
-                                          <p:spTgt spid="22"/>
-                                        </p:tgtEl>
-                                      </p:cBhvr>
-                                    </p:animEffect>
-                                  </p:childTnLst>
-                                </p:cTn>
-                              </p:par>
-                              <p:par>
-                                <p:cTn id="74" presetID="10" presetClass="entr" presetSubtype="0" fill="hold" grpId="0" nodeType="withEffect">
-                                  <p:stCondLst>
-                                    <p:cond delay="0"/>
-                                  </p:stCondLst>
-                                  <p:childTnLst>
-                                    <p:set>
-                                      <p:cBhvr>
-                                        <p:cTn id="75" dur="1" fill="hold">
-                                          <p:stCondLst>
-                                            <p:cond delay="0"/>
-                                          </p:stCondLst>
-                                        </p:cTn>
-                                        <p:tgtEl>
-                                          <p:spTgt spid="23"/>
-                                        </p:tgtEl>
-                                        <p:attrNameLst>
-                                          <p:attrName>style.visibility</p:attrName>
-                                        </p:attrNameLst>
-                                      </p:cBhvr>
-                                      <p:to>
-                                        <p:strVal val="visible"/>
-                                      </p:to>
-                                    </p:set>
-                                    <p:animEffect transition="in" filter="fade">
-                                      <p:cBhvr>
-                                        <p:cTn id="76" dur="500"/>
-                                        <p:tgtEl>
-                                          <p:spTgt spid="23"/>
-                                        </p:tgtEl>
-                                      </p:cBhvr>
-                                    </p:animEffect>
-                                  </p:childTnLst>
-                                </p:cTn>
-                              </p:par>
-                              <p:par>
-                                <p:cTn id="77" presetID="10" presetClass="entr" presetSubtype="0" fill="hold" grpId="0" nodeType="withEffect">
-                                  <p:stCondLst>
-                                    <p:cond delay="0"/>
-                                  </p:stCondLst>
-                                  <p:childTnLst>
-                                    <p:set>
-                                      <p:cBhvr>
-                                        <p:cTn id="78" dur="1" fill="hold">
-                                          <p:stCondLst>
-                                            <p:cond delay="0"/>
-                                          </p:stCondLst>
-                                        </p:cTn>
-                                        <p:tgtEl>
-                                          <p:spTgt spid="24"/>
-                                        </p:tgtEl>
-                                        <p:attrNameLst>
-                                          <p:attrName>style.visibility</p:attrName>
-                                        </p:attrNameLst>
-                                      </p:cBhvr>
-                                      <p:to>
-                                        <p:strVal val="visible"/>
-                                      </p:to>
-                                    </p:set>
-                                    <p:animEffect transition="in" filter="fade">
-                                      <p:cBhvr>
                                         <p:cTn id="79" dur="500"/>
-                                        <p:tgtEl>
-                                          <p:spTgt spid="24"/>
-                                        </p:tgtEl>
-                                      </p:cBhvr>
-                                    </p:animEffect>
-                                  </p:childTnLst>
-                                </p:cTn>
-                              </p:par>
-                              <p:par>
-                                <p:cTn id="80" presetID="10" presetClass="entr" presetSubtype="0" fill="hold" grpId="0" nodeType="withEffect">
-                                  <p:stCondLst>
-                                    <p:cond delay="0"/>
-                                  </p:stCondLst>
-                                  <p:childTnLst>
-                                    <p:set>
-                                      <p:cBhvr>
-                                        <p:cTn id="81" dur="1" fill="hold">
-                                          <p:stCondLst>
-                                            <p:cond delay="0"/>
-                                          </p:stCondLst>
-                                        </p:cTn>
-                                        <p:tgtEl>
-                                          <p:spTgt spid="25"/>
-                                        </p:tgtEl>
-                                        <p:attrNameLst>
-                                          <p:attrName>style.visibility</p:attrName>
-                                        </p:attrNameLst>
-                                      </p:cBhvr>
-                                      <p:to>
-                                        <p:strVal val="visible"/>
-                                      </p:to>
-                                    </p:set>
-                                    <p:animEffect transition="in" filter="fade">
-                                      <p:cBhvr>
-                                        <p:cTn id="82" dur="500"/>
-                                        <p:tgtEl>
-                                          <p:spTgt spid="25"/>
-                                        </p:tgtEl>
-                                      </p:cBhvr>
-                                    </p:animEffect>
-                                  </p:childTnLst>
-                                </p:cTn>
-                              </p:par>
-                              <p:par>
-                                <p:cTn id="83" presetID="10" presetClass="entr" presetSubtype="0" fill="hold" grpId="0" nodeType="withEffect">
-                                  <p:stCondLst>
-                                    <p:cond delay="0"/>
-                                  </p:stCondLst>
-                                  <p:childTnLst>
-                                    <p:set>
-                                      <p:cBhvr>
-                                        <p:cTn id="84" dur="1" fill="hold">
-                                          <p:stCondLst>
-                                            <p:cond delay="0"/>
-                                          </p:stCondLst>
-                                        </p:cTn>
-                                        <p:tgtEl>
-                                          <p:spTgt spid="26"/>
-                                        </p:tgtEl>
-                                        <p:attrNameLst>
-                                          <p:attrName>style.visibility</p:attrName>
-                                        </p:attrNameLst>
-                                      </p:cBhvr>
-                                      <p:to>
-                                        <p:strVal val="visible"/>
-                                      </p:to>
-                                    </p:set>
-                                    <p:animEffect transition="in" filter="fade">
-                                      <p:cBhvr>
-                                        <p:cTn id="85" dur="500"/>
-                                        <p:tgtEl>
-                                          <p:spTgt spid="26"/>
-                                        </p:tgtEl>
-                                      </p:cBhvr>
-                                    </p:animEffect>
-                                  </p:childTnLst>
-                                </p:cTn>
-                              </p:par>
-                            </p:childTnLst>
-                          </p:cTn>
-                        </p:par>
-                      </p:childTnLst>
-                    </p:cTn>
-                  </p:par>
-                  <p:par>
-                    <p:cTn id="86" fill="hold">
-                      <p:stCondLst>
-                        <p:cond delay="indefinite"/>
-                      </p:stCondLst>
-                      <p:childTnLst>
-                        <p:par>
-                          <p:cTn id="87" fill="hold">
-                            <p:stCondLst>
-                              <p:cond delay="0"/>
-                            </p:stCondLst>
-                            <p:childTnLst>
-                              <p:par>
-                                <p:cTn id="88" presetID="22" presetClass="entr" presetSubtype="8" fill="hold" nodeType="clickEffect">
-                                  <p:stCondLst>
-                                    <p:cond delay="0"/>
-                                  </p:stCondLst>
-                                  <p:childTnLst>
-                                    <p:set>
-                                      <p:cBhvr>
-                                        <p:cTn id="89" dur="1" fill="hold">
-                                          <p:stCondLst>
-                                            <p:cond delay="0"/>
-                                          </p:stCondLst>
-                                        </p:cTn>
-                                        <p:tgtEl>
-                                          <p:spTgt spid="27"/>
-                                        </p:tgtEl>
-                                        <p:attrNameLst>
-                                          <p:attrName>style.visibility</p:attrName>
-                                        </p:attrNameLst>
-                                      </p:cBhvr>
-                                      <p:to>
-                                        <p:strVal val="visible"/>
-                                      </p:to>
-                                    </p:set>
-                                    <p:animEffect transition="in" filter="wipe(left)">
-                                      <p:cBhvr>
-                                        <p:cTn id="90" dur="600"/>
-                                        <p:tgtEl>
-                                          <p:spTgt spid="27"/>
-                                        </p:tgtEl>
-                                      </p:cBhvr>
-                                    </p:animEffect>
-                                  </p:childTnLst>
-                                </p:cTn>
-                              </p:par>
-                              <p:par>
-                                <p:cTn id="91" presetID="10" presetClass="entr" presetSubtype="0" fill="hold" grpId="0" nodeType="withEffect">
-                                  <p:stCondLst>
-                                    <p:cond delay="0"/>
-                                  </p:stCondLst>
-                                  <p:childTnLst>
-                                    <p:set>
-                                      <p:cBhvr>
-                                        <p:cTn id="92" dur="1" fill="hold">
-                                          <p:stCondLst>
-                                            <p:cond delay="0"/>
-                                          </p:stCondLst>
-                                        </p:cTn>
-                                        <p:tgtEl>
-                                          <p:spTgt spid="28"/>
-                                        </p:tgtEl>
-                                        <p:attrNameLst>
-                                          <p:attrName>style.visibility</p:attrName>
-                                        </p:attrNameLst>
-                                      </p:cBhvr>
-                                      <p:to>
-                                        <p:strVal val="visible"/>
-                                      </p:to>
-                                    </p:set>
-                                    <p:animEffect transition="in" filter="fade">
-                                      <p:cBhvr>
-                                        <p:cTn id="93" dur="500"/>
                                         <p:tgtEl>
                                           <p:spTgt spid="28"/>
                                         </p:tgtEl>
@@ -22204,7 +20093,6 @@
       <p:bldP spid="4" grpId="0" animBg="1"/>
       <p:bldP spid="5" grpId="0" animBg="1"/>
       <p:bldP spid="6" grpId="0" animBg="1"/>
-      <p:bldP spid="7" grpId="0" animBg="1"/>
       <p:bldP spid="8" grpId="0" animBg="1"/>
       <p:bldP spid="10" grpId="0" animBg="1"/>
       <p:bldP spid="11" grpId="0" animBg="1"/>
@@ -22216,8 +20104,6 @@
         <p:bldAsOne/>
       </p:bldGraphic>
       <p:bldP spid="18" grpId="0" animBg="1"/>
-      <p:bldP spid="19" grpId="0" animBg="1"/>
-      <p:bldP spid="21" grpId="0" animBg="1"/>
       <p:bldP spid="22" grpId="0" animBg="1"/>
       <p:bldP spid="23" grpId="0" animBg="1"/>
       <p:bldP spid="24" grpId="0" animBg="1"/>
@@ -22775,21 +20661,78 @@
           <a:bodyPr wrap="square" lIns="0" tIns="0" rIns="0" bIns="0" rtlCol="0" anchor="ctr"/>
           <a:lstStyle/>
           <a:p>
-            <a:pPr marL="0" indent="0">
-              <a:lnSpc>
-                <a:spcPct val="100000"/>
-              </a:lnSpc>
-              <a:buNone/>
-            </a:pPr>
             <a:r>
               <a:rPr lang="en-US" sz="1400" dirty="0">
                 <a:solidFill>
                   <a:schemeClr val="bg1"/>
                 </a:solidFill>
               </a:rPr>
-              <a:t>We predict whether a food is high in fat, with the fat amount removed from the features, and we split by category so no category is on both sides; a split by date would leak. GraphSAGE has a higher mean than logistic regression, but the spread between seeds is larger than the gap, so we do not call it better. For link prediction, TransE loses to a simple popularity count on every seed, and we report it as it is.</a:t>
+              <a:t>We ran three experiments: </a:t>
             </a:r>
-            <a:endParaRPr lang="en-US" sz="1400" dirty="0"/>
+            <a:r>
+              <a:rPr lang="en-US" sz="1400" b="1" dirty="0">
+                <a:solidFill>
+                  <a:schemeClr val="bg1"/>
+                </a:solidFill>
+              </a:rPr>
+              <a:t>logistic regression</a:t>
+            </a:r>
+            <a:r>
+              <a:rPr lang="en-US" sz="1400" dirty="0">
+                <a:solidFill>
+                  <a:schemeClr val="bg1"/>
+                </a:solidFill>
+              </a:rPr>
+              <a:t>, a simple model that predicts whether a food is high in fat from its nutrient information; </a:t>
+            </a:r>
+            <a:r>
+              <a:rPr lang="en-US" sz="1400" b="1" dirty="0" err="1">
+                <a:solidFill>
+                  <a:schemeClr val="bg1"/>
+                </a:solidFill>
+              </a:rPr>
+              <a:t>GraphSAGE</a:t>
+            </a:r>
+            <a:r>
+              <a:rPr lang="en-US" sz="1400" dirty="0">
+                <a:solidFill>
+                  <a:schemeClr val="bg1"/>
+                </a:solidFill>
+              </a:rPr>
+              <a:t>, which uses food features and graph connections for the same prediction; and </a:t>
+            </a:r>
+            <a:r>
+              <a:rPr lang="en-US" sz="1400" b="1" dirty="0">
+                <a:solidFill>
+                  <a:schemeClr val="bg1"/>
+                </a:solidFill>
+              </a:rPr>
+              <a:t>TransE</a:t>
+            </a:r>
+            <a:r>
+              <a:rPr lang="en-US" sz="1400" dirty="0">
+                <a:solidFill>
+                  <a:schemeClr val="bg1"/>
+                </a:solidFill>
+              </a:rPr>
+              <a:t>, which predicts missing links between foods and categories. We hid fat amounts from the classification inputs and used separate categories for training and testing. </a:t>
+            </a:r>
+            <a:r>
+              <a:rPr lang="en-US" sz="1400" dirty="0" err="1">
+                <a:solidFill>
+                  <a:schemeClr val="bg1"/>
+                </a:solidFill>
+              </a:rPr>
+              <a:t>GraphSAGE</a:t>
+            </a:r>
+            <a:r>
+              <a:rPr lang="en-US" sz="1400" dirty="0">
+                <a:solidFill>
+                  <a:schemeClr val="bg1"/>
+                </a:solidFill>
+              </a:rPr>
+              <a:t> showed no consistent advantage over logistic regression, while TransE performed worse than a simple popularity-based method.</a:t>
+            </a:r>
           </a:p>
         </p:txBody>
       </p:sp>
@@ -22813,7 +20756,7 @@
           </a:prstGeom>
           <a:extLst>
             <a:ext uri="{C572A759-6A51-4108-AA02-DFA0A04FC94B}">
-              <ma14:wrappingTextBoxFlag xmlns:ma14="http://schemas.microsoft.com/office/mac/drawingml/2011/main" xmlns="" val="0"/>
+              <ma14:wrappingTextBoxFlag xmlns="" xmlns:ma14="http://schemas.microsoft.com/office/mac/drawingml/2011/main" val="0"/>
             </a:ext>
           </a:extLst>
         </p:spPr>
@@ -24799,27 +22742,21 @@
           <a:bodyPr wrap="square" lIns="0" tIns="0" rIns="0" bIns="0" rtlCol="0" anchor="ctr"/>
           <a:lstStyle/>
           <a:p>
-            <a:pPr marL="0" indent="0">
-              <a:lnSpc>
-                <a:spcPct val="100000"/>
-              </a:lnSpc>
-              <a:buNone/>
-            </a:pPr>
             <a:r>
               <a:rPr lang="en-US" sz="1400" dirty="0">
                 <a:solidFill>
                   <a:schemeClr val="bg1"/>
                 </a:solidFill>
               </a:rPr>
-              <a:t>A question in English becomes a prompt with the graph’s description, our naming rules and the three closest example queries. Gemini writes one SPARQL query; we check that it uses only real classes and properties, let Gemini repair it up to two times, or refuse. On </a:t>
+              <a:t>Users ask questions in English, and </a:t>
             </a:r>
             <a:r>
               <a:rPr lang="en-US" sz="1400" b="1" dirty="0">
                 <a:solidFill>
-                  <a:schemeClr val="accent6"/>
+                  <a:schemeClr val="bg1"/>
                 </a:solidFill>
               </a:rPr>
-              <a:t>11</a:t>
+              <a:t>Gemini turns them into SPARQL queries</a:t>
             </a:r>
             <a:r>
               <a:rPr lang="en-US" sz="1400" dirty="0">
@@ -24827,15 +22764,15 @@
                   <a:schemeClr val="bg1"/>
                 </a:solidFill>
               </a:rPr>
-              <a:t> test questions, examples raised the mean F1 from </a:t>
+              <a:t> using the graph’s description, naming rules, and three similar examples. The system checks each query and allows up to two corrections before returning results or explaining why it cannot answer. Adding examples improved the average </a:t>
             </a:r>
             <a:r>
               <a:rPr lang="en-US" sz="1400" b="1" dirty="0">
                 <a:solidFill>
-                  <a:schemeClr val="accent6"/>
+                  <a:schemeClr val="bg1"/>
                 </a:solidFill>
               </a:rPr>
-              <a:t>0.856</a:t>
+              <a:t>F1 score from 0.856 to 0.954 across eight answerable questions</a:t>
             </a:r>
             <a:r>
               <a:rPr lang="en-US" sz="1400" dirty="0">
@@ -24843,25 +22780,8 @@
                   <a:schemeClr val="bg1"/>
                 </a:solidFill>
               </a:rPr>
-              <a:t> to </a:t>
+              <a:t>. All three questions about unavailable data were refused with a clear reason.</a:t>
             </a:r>
-            <a:r>
-              <a:rPr lang="en-US" sz="1400" b="1" dirty="0">
-                <a:solidFill>
-                  <a:schemeClr val="accent6"/>
-                </a:solidFill>
-              </a:rPr>
-              <a:t>0.954</a:t>
-            </a:r>
-            <a:r>
-              <a:rPr lang="en-US" sz="1400" dirty="0">
-                <a:solidFill>
-                  <a:schemeClr val="bg1"/>
-                </a:solidFill>
-              </a:rPr>
-              <a:t>, and all three unanswerable questions were refused with a reason.</a:t>
-            </a:r>
-            <a:endParaRPr lang="en-US" sz="1400" dirty="0"/>
           </a:p>
         </p:txBody>
       </p:sp>
@@ -24885,7 +22805,7 @@
           </a:prstGeom>
           <a:extLst>
             <a:ext uri="{C572A759-6A51-4108-AA02-DFA0A04FC94B}">
-              <ma14:wrappingTextBoxFlag xmlns:ma14="http://schemas.microsoft.com/office/mac/drawingml/2011/main" xmlns="" val="0"/>
+              <ma14:wrappingTextBoxFlag xmlns="" xmlns:ma14="http://schemas.microsoft.com/office/mac/drawingml/2011/main" val="0"/>
             </a:ext>
           </a:extLst>
         </p:spPr>

</xml_diff>